<commit_message>
Présentation aux couleurs du logo, avec logo et photos des actions
- Palette reprise du logo : bleu, orange, vert, violet
- Logo sur la diapo de titre et la diapo de remerciements
- Nouvelle diapositive « Nos actions en images » avec 3 photos
  (distribution dans les orphelinats, kits scolaires)

Co-Authored-By: Claude Fable 5 <noreply@anthropic.com>
Claude-Session: https://claude.ai/code/session_018pxe1k876zoUh9KcphmN1E
</commit_message>
<xml_diff>
--- a/presentation-les-petits-enfants-de-marie.pptx
+++ b/presentation-les-petits-enfants-de-marie.pptx
@@ -13,9 +13,10 @@
     <p:sldId id="261" r:id="rId7"/>
     <p:sldId id="262" r:id="rId8"/>
     <p:sldId id="263" r:id="rId9"/>
+    <p:sldId id="264" r:id="rId10"/>
   </p:sldIdLst>
   <p:notesMasterIdLst>
-    <p:notesMasterId r:id="rId10"/>
+    <p:notesMasterId r:id="rId11"/>
   </p:notesMasterIdLst>
   <p:sldSz cx="12192000" cy="6858000"/>
   <p:notesSz cx="6858000" cy="12192000"/>
@@ -1167,6 +1168,94 @@
 </p:notes>
 </file>
 
+<file path=ppt/notesSlides/notesSlide9.xml><?xml version="1.0" encoding="utf-8"?>
+<p:notes xmlns:a="http://schemas.openxmlformats.org/drawingml/2006/main" xmlns:r="http://schemas.openxmlformats.org/officeDocument/2006/relationships" xmlns:p="http://schemas.openxmlformats.org/presentationml/2006/main">
+  <p:cSld>
+    <p:spTree>
+      <p:nvGrpSpPr>
+        <p:cNvPr id="1" name=""/>
+        <p:cNvGrpSpPr/>
+        <p:nvPr/>
+      </p:nvGrpSpPr>
+      <p:grpSpPr>
+        <a:xfrm>
+          <a:off x="0" y="0"/>
+          <a:ext cx="0" cy="0"/>
+          <a:chOff x="0" y="0"/>
+          <a:chExt cx="0" cy="0"/>
+        </a:xfrm>
+      </p:grpSpPr>
+      <p:sp>
+        <p:nvSpPr>
+          <p:cNvPr id="2" name="Slide Image Placeholder 1"/>
+          <p:cNvSpPr>
+            <a:spLocks noGrp="1" noRot="1" noChangeAspect="1"/>
+          </p:cNvSpPr>
+          <p:nvPr>
+            <p:ph type="sldImg"/>
+          </p:nvPr>
+        </p:nvSpPr>
+        <p:spPr/>
+      </p:sp>
+      <p:sp>
+        <p:nvSpPr>
+          <p:cNvPr id="3" name="Notes Placeholder 2"/>
+          <p:cNvSpPr>
+            <a:spLocks noGrp="1"/>
+          </p:cNvSpPr>
+          <p:nvPr>
+            <p:ph type="body" idx="1"/>
+          </p:nvPr>
+        </p:nvSpPr>
+        <p:spPr/>
+        <p:txBody>
+          <a:bodyPr/>
+          <a:lstStyle/>
+          <a:p>
+            <a:r>
+              <a:rPr lang="en-US" dirty="0"/>
+              <a:t/>
+            </a:r>
+            <a:endParaRPr lang="en-US" dirty="0"/>
+          </a:p>
+        </p:txBody>
+      </p:sp>
+      <p:sp>
+        <p:nvSpPr>
+          <p:cNvPr id="4" name="Slide Number Placeholder 3"/>
+          <p:cNvSpPr>
+            <a:spLocks noGrp="1"/>
+          </p:cNvSpPr>
+          <p:nvPr>
+            <p:ph type="sldNum" sz="quarter" idx="10"/>
+          </p:nvPr>
+        </p:nvSpPr>
+        <p:spPr/>
+        <p:txBody>
+          <a:bodyPr/>
+          <a:lstStyle/>
+          <a:p>
+            <a:fld id="{F7021451-1387-4CA6-816F-3879F97B5CBC}" type="slidenum">
+              <a:rPr lang="en-US"/>
+              <a:t>9</a:t>
+            </a:fld>
+            <a:endParaRPr lang="en-US"/>
+          </a:p>
+        </p:txBody>
+      </p:sp>
+    </p:spTree>
+    <p:extLst>
+      <p:ext uri="{BB962C8B-B14F-4D97-AF65-F5344CB8AC3E}">
+        <p14:creationId xmlns:p14="http://schemas.microsoft.com/office/powerpoint/2010/main" val="1024086991"/>
+      </p:ext>
+    </p:extLst>
+  </p:cSld>
+  <p:clrMapOvr>
+    <a:masterClrMapping/>
+  </p:clrMapOvr>
+</p:notes>
+</file>
+
 <file path=ppt/slideLayouts/slideLayout1.xml><?xml version="1.0" encoding="utf-8"?>
 <p:sldLayout xmlns:a="http://schemas.openxmlformats.org/drawingml/2006/main" xmlns:r="http://schemas.openxmlformats.org/officeDocument/2006/relationships" xmlns:p="http://schemas.openxmlformats.org/presentationml/2006/main" preserve="1">
   <p:cSld name="DEFAULT">
@@ -1480,7 +1569,7 @@
     <p:bg>
       <p:bgPr>
         <a:solidFill>
-          <a:srgbClr val="2F3C7E"/>
+          <a:srgbClr val="FFFFFF"/>
         </a:solidFill>
       </p:bgPr>
     </p:bg>
@@ -1506,14 +1595,16 @@
         </p:nvSpPr>
         <p:spPr>
           <a:xfrm>
-            <a:off x="10149840" y="-1463040"/>
-            <a:ext cx="4023360" cy="4023360"/>
+            <a:off x="10515600" y="-1280160"/>
+            <a:ext cx="3291840" cy="3291840"/>
           </a:xfrm>
           <a:prstGeom prst="ellipse">
             <a:avLst/>
           </a:prstGeom>
           <a:solidFill>
-            <a:srgbClr val="242E63"/>
+            <a:srgbClr val="6CDBFE">
+              <a:alpha val="45000"/>
+            </a:srgbClr>
           </a:solidFill>
           <a:ln/>
         </p:spPr>
@@ -1526,14 +1617,16 @@
         </p:nvSpPr>
         <p:spPr>
           <a:xfrm>
-            <a:off x="-1645920" y="4846320"/>
-            <a:ext cx="4206240" cy="4206240"/>
+            <a:off x="-1371600" y="5120640"/>
+            <a:ext cx="3474720" cy="3474720"/>
           </a:xfrm>
           <a:prstGeom prst="ellipse">
             <a:avLst/>
           </a:prstGeom>
           <a:solidFill>
-            <a:srgbClr val="242E63"/>
+            <a:srgbClr val="F9931D">
+              <a:alpha val="40000"/>
+            </a:srgbClr>
           </a:solidFill>
           <a:ln/>
         </p:spPr>
@@ -1546,21 +1639,45 @@
         </p:nvSpPr>
         <p:spPr>
           <a:xfrm>
-            <a:off x="5541264" y="777240"/>
-            <a:ext cx="1097280" cy="1097280"/>
+            <a:off x="11292840" y="5394960"/>
+            <a:ext cx="2011680" cy="2011680"/>
           </a:xfrm>
           <a:prstGeom prst="ellipse">
             <a:avLst/>
           </a:prstGeom>
           <a:solidFill>
-            <a:srgbClr val="F96167"/>
+            <a:srgbClr val="94268F">
+              <a:alpha val="40000"/>
+            </a:srgbClr>
+          </a:solidFill>
+          <a:ln/>
+        </p:spPr>
+      </p:sp>
+      <p:sp>
+        <p:nvSpPr>
+          <p:cNvPr id="5" name="Shape 3"/>
+          <p:cNvSpPr/>
+          <p:nvPr/>
+        </p:nvSpPr>
+        <p:spPr>
+          <a:xfrm>
+            <a:off x="-731520" y="-1005840"/>
+            <a:ext cx="2377440" cy="2377440"/>
+          </a:xfrm>
+          <a:prstGeom prst="ellipse">
+            <a:avLst/>
+          </a:prstGeom>
+          <a:solidFill>
+            <a:srgbClr val="45B84B">
+              <a:alpha val="40000"/>
+            </a:srgbClr>
           </a:solidFill>
           <a:ln/>
         </p:spPr>
       </p:sp>
       <p:pic>
         <p:nvPicPr>
-          <p:cNvPr id="5" name="Image 0" descr="preencoded.png">    </p:cNvPr>
+          <p:cNvPr id="6" name="Image 0" descr="preencoded.png">    </p:cNvPr>
           <p:cNvPicPr>
             <a:picLocks noChangeAspect="1"/>
           </p:cNvPicPr>
@@ -1574,8 +1691,8 @@
         </p:blipFill>
         <p:spPr>
           <a:xfrm>
-            <a:off x="5826557" y="1062533"/>
-            <a:ext cx="526694" cy="526694"/>
+            <a:off x="4768596" y="502920"/>
+            <a:ext cx="2651760" cy="2651760"/>
           </a:xfrm>
           <a:prstGeom prst="rect">
             <a:avLst/>
@@ -1584,14 +1701,14 @@
       </p:pic>
       <p:sp>
         <p:nvSpPr>
-          <p:cNvPr id="6" name="Text 3"/>
-          <p:cNvSpPr/>
-          <p:nvPr/>
-        </p:nvSpPr>
-        <p:spPr>
-          <a:xfrm>
-            <a:off x="640080" y="2057400"/>
-            <a:ext cx="10908792" cy="914400"/>
+          <p:cNvPr id="7" name="Text 4"/>
+          <p:cNvSpPr/>
+          <p:nvPr/>
+        </p:nvSpPr>
+        <p:spPr>
+          <a:xfrm>
+            <a:off x="640080" y="3429000"/>
+            <a:ext cx="10908792" cy="868680"/>
           </a:xfrm>
           <a:prstGeom prst="rect">
             <a:avLst/>
@@ -1607,9 +1724,9 @@
               <a:buNone/>
             </a:pPr>
             <a:r>
-              <a:rPr lang="en-US" sz="4400" b="1" dirty="0">
-                <a:solidFill>
-                  <a:srgbClr val="FFFFFF"/>
+              <a:rPr lang="en-US" sz="4000" b="1" dirty="0">
+                <a:solidFill>
+                  <a:srgbClr val="2F3C7E"/>
                 </a:solidFill>
                 <a:latin typeface="Cambria" pitchFamily="34" charset="0"/>
                 <a:ea typeface="Cambria" pitchFamily="34" charset="-122"/>
@@ -1617,20 +1734,20 @@
               </a:rPr>
               <a:t>LES PETITS ENFANTS DE MARIE</a:t>
             </a:r>
-            <a:endParaRPr lang="en-US" sz="4400" dirty="0"/>
-          </a:p>
-        </p:txBody>
-      </p:sp>
-      <p:sp>
-        <p:nvSpPr>
-          <p:cNvPr id="7" name="Text 4"/>
-          <p:cNvSpPr/>
-          <p:nvPr/>
-        </p:nvSpPr>
-        <p:spPr>
-          <a:xfrm>
-            <a:off x="640080" y="3063240"/>
-            <a:ext cx="10908792" cy="640080"/>
+            <a:endParaRPr lang="en-US" sz="4000" dirty="0"/>
+          </a:p>
+        </p:txBody>
+      </p:sp>
+      <p:sp>
+        <p:nvSpPr>
+          <p:cNvPr id="8" name="Text 5"/>
+          <p:cNvSpPr/>
+          <p:nvPr/>
+        </p:nvSpPr>
+        <p:spPr>
+          <a:xfrm>
+            <a:off x="640080" y="4343400"/>
+            <a:ext cx="10908792" cy="548640"/>
           </a:xfrm>
           <a:prstGeom prst="rect">
             <a:avLst/>
@@ -1648,7 +1765,7 @@
             <a:r>
               <a:rPr lang="en-US" sz="1800" i="1" dirty="0">
                 <a:solidFill>
-                  <a:srgbClr val="F9E795"/>
+                  <a:srgbClr val="F9931D"/>
                 </a:solidFill>
                 <a:latin typeface="Cambria" pitchFamily="34" charset="0"/>
                 <a:ea typeface="Cambria" pitchFamily="34" charset="-122"/>
@@ -1662,14 +1779,14 @@
       </p:sp>
       <p:sp>
         <p:nvSpPr>
-          <p:cNvPr id="8" name="Text 5"/>
-          <p:cNvSpPr/>
-          <p:nvPr/>
-        </p:nvSpPr>
-        <p:spPr>
-          <a:xfrm>
-            <a:off x="640080" y="5120640"/>
-            <a:ext cx="10908792" cy="822960"/>
+          <p:cNvPr id="9" name="Text 6"/>
+          <p:cNvSpPr/>
+          <p:nvPr/>
+        </p:nvSpPr>
+        <p:spPr>
+          <a:xfrm>
+            <a:off x="640080" y="5349240"/>
+            <a:ext cx="10908792" cy="777240"/>
           </a:xfrm>
           <a:prstGeom prst="rect">
             <a:avLst/>
@@ -1685,9 +1802,9 @@
               <a:buNone/>
             </a:pPr>
             <a:r>
-              <a:rPr lang="en-US" sz="1600" dirty="0">
-                <a:solidFill>
-                  <a:srgbClr val="C9CFEA"/>
+              <a:rPr lang="en-US" sz="1500" dirty="0">
+                <a:solidFill>
+                  <a:srgbClr val="5A5A6E"/>
                 </a:solidFill>
                 <a:latin typeface="Calibri" pitchFamily="34" charset="0"/>
                 <a:ea typeface="Calibri" pitchFamily="34" charset="-122"/>
@@ -1695,16 +1812,16 @@
               </a:rPr>
               <a:t>Présentation de l’association</a:t>
             </a:r>
-            <a:endParaRPr lang="en-US" sz="1600" dirty="0"/>
+            <a:endParaRPr lang="en-US" sz="1500" dirty="0"/>
           </a:p>
           <a:p>
             <a:pPr algn="ctr" indent="0" marL="0">
               <a:buNone/>
             </a:pPr>
             <a:r>
-              <a:rPr lang="en-US" sz="1600" b="1" dirty="0">
-                <a:solidFill>
-                  <a:srgbClr val="FFFFFF"/>
+              <a:rPr lang="en-US" sz="1500" b="1" dirty="0">
+                <a:solidFill>
+                  <a:srgbClr val="2F3C7E"/>
                 </a:solidFill>
                 <a:latin typeface="Calibri" pitchFamily="34" charset="0"/>
                 <a:ea typeface="Calibri" pitchFamily="34" charset="-122"/>
@@ -1712,7 +1829,7 @@
               </a:rPr>
               <a:t>Ariane Orou Gabe — Fondatrice</a:t>
             </a:r>
-            <a:endParaRPr lang="en-US" sz="1600" dirty="0"/>
+            <a:endParaRPr lang="en-US" sz="1500" dirty="0"/>
           </a:p>
         </p:txBody>
       </p:sp>
@@ -1750,7 +1867,87 @@
       </p:grpSpPr>
       <p:sp>
         <p:nvSpPr>
-          <p:cNvPr id="2" name="Text 0"/>
+          <p:cNvPr id="2" name="Shape 0"/>
+          <p:cNvSpPr/>
+          <p:nvPr/>
+        </p:nvSpPr>
+        <p:spPr>
+          <a:xfrm>
+            <a:off x="11612880" y="365760"/>
+            <a:ext cx="256032" cy="256032"/>
+          </a:xfrm>
+          <a:prstGeom prst="ellipse">
+            <a:avLst/>
+          </a:prstGeom>
+          <a:solidFill>
+            <a:srgbClr val="F9931D"/>
+          </a:solidFill>
+          <a:ln/>
+        </p:spPr>
+      </p:sp>
+      <p:sp>
+        <p:nvSpPr>
+          <p:cNvPr id="3" name="Shape 1"/>
+          <p:cNvSpPr/>
+          <p:nvPr/>
+        </p:nvSpPr>
+        <p:spPr>
+          <a:xfrm>
+            <a:off x="384048" y="5989320"/>
+            <a:ext cx="201168" cy="201168"/>
+          </a:xfrm>
+          <a:prstGeom prst="ellipse">
+            <a:avLst/>
+          </a:prstGeom>
+          <a:solidFill>
+            <a:srgbClr val="45B84B"/>
+          </a:solidFill>
+          <a:ln/>
+        </p:spPr>
+      </p:sp>
+      <p:sp>
+        <p:nvSpPr>
+          <p:cNvPr id="4" name="Shape 2"/>
+          <p:cNvSpPr/>
+          <p:nvPr/>
+        </p:nvSpPr>
+        <p:spPr>
+          <a:xfrm>
+            <a:off x="11109960" y="6126480"/>
+            <a:ext cx="274320" cy="274320"/>
+          </a:xfrm>
+          <a:prstGeom prst="ellipse">
+            <a:avLst/>
+          </a:prstGeom>
+          <a:solidFill>
+            <a:srgbClr val="94268F"/>
+          </a:solidFill>
+          <a:ln/>
+        </p:spPr>
+      </p:sp>
+      <p:sp>
+        <p:nvSpPr>
+          <p:cNvPr id="5" name="Shape 3"/>
+          <p:cNvSpPr/>
+          <p:nvPr/>
+        </p:nvSpPr>
+        <p:spPr>
+          <a:xfrm>
+            <a:off x="822960" y="6382512"/>
+            <a:ext cx="182880" cy="182880"/>
+          </a:xfrm>
+          <a:prstGeom prst="ellipse">
+            <a:avLst/>
+          </a:prstGeom>
+          <a:solidFill>
+            <a:srgbClr val="6CDBFE"/>
+          </a:solidFill>
+          <a:ln/>
+        </p:spPr>
+      </p:sp>
+      <p:sp>
+        <p:nvSpPr>
+          <p:cNvPr id="6" name="Text 4"/>
           <p:cNvSpPr/>
           <p:nvPr/>
         </p:nvSpPr>
@@ -1789,7 +1986,7 @@
       </p:sp>
       <p:sp>
         <p:nvSpPr>
-          <p:cNvPr id="3" name="Text 1"/>
+          <p:cNvPr id="7" name="Text 5"/>
           <p:cNvSpPr/>
           <p:nvPr/>
         </p:nvSpPr>
@@ -1902,7 +2099,7 @@
       </p:sp>
       <p:sp>
         <p:nvSpPr>
-          <p:cNvPr id="4" name="Shape 2"/>
+          <p:cNvPr id="8" name="Shape 6"/>
           <p:cNvSpPr/>
           <p:nvPr/>
         </p:nvSpPr>
@@ -1931,7 +2128,7 @@
       </p:sp>
       <p:sp>
         <p:nvSpPr>
-          <p:cNvPr id="5" name="Shape 3"/>
+          <p:cNvPr id="9" name="Shape 7"/>
           <p:cNvSpPr/>
           <p:nvPr/>
         </p:nvSpPr>
@@ -1944,14 +2141,14 @@
             <a:avLst/>
           </a:prstGeom>
           <a:solidFill>
-            <a:srgbClr val="2F3C7E"/>
+            <a:srgbClr val="2BA8E0"/>
           </a:solidFill>
           <a:ln/>
         </p:spPr>
       </p:sp>
       <p:pic>
         <p:nvPicPr>
-          <p:cNvPr id="6" name="Image 0" descr="preencoded.png">    </p:cNvPr>
+          <p:cNvPr id="10" name="Image 0" descr="preencoded.png">    </p:cNvPr>
           <p:cNvPicPr>
             <a:picLocks noChangeAspect="1"/>
           </p:cNvPicPr>
@@ -1975,7 +2172,7 @@
       </p:pic>
       <p:sp>
         <p:nvSpPr>
-          <p:cNvPr id="7" name="Text 4"/>
+          <p:cNvPr id="11" name="Text 8"/>
           <p:cNvSpPr/>
           <p:nvPr/>
         </p:nvSpPr>
@@ -2014,7 +2211,7 @@
       </p:sp>
       <p:sp>
         <p:nvSpPr>
-          <p:cNvPr id="8" name="Text 5"/>
+          <p:cNvPr id="12" name="Text 9"/>
           <p:cNvSpPr/>
           <p:nvPr/>
         </p:nvSpPr>
@@ -2053,7 +2250,7 @@
       </p:sp>
       <p:sp>
         <p:nvSpPr>
-          <p:cNvPr id="9" name="Shape 6"/>
+          <p:cNvPr id="13" name="Shape 10"/>
           <p:cNvSpPr/>
           <p:nvPr/>
         </p:nvSpPr>
@@ -2082,7 +2279,7 @@
       </p:sp>
       <p:sp>
         <p:nvSpPr>
-          <p:cNvPr id="10" name="Shape 7"/>
+          <p:cNvPr id="14" name="Shape 11"/>
           <p:cNvSpPr/>
           <p:nvPr/>
         </p:nvSpPr>
@@ -2095,14 +2292,14 @@
             <a:avLst/>
           </a:prstGeom>
           <a:solidFill>
-            <a:srgbClr val="F96167"/>
+            <a:srgbClr val="F9931D"/>
           </a:solidFill>
           <a:ln/>
         </p:spPr>
       </p:sp>
       <p:pic>
         <p:nvPicPr>
-          <p:cNvPr id="11" name="Image 1" descr="preencoded.png">    </p:cNvPr>
+          <p:cNvPr id="15" name="Image 1" descr="preencoded.png">    </p:cNvPr>
           <p:cNvPicPr>
             <a:picLocks noChangeAspect="1"/>
           </p:cNvPicPr>
@@ -2126,7 +2323,7 @@
       </p:pic>
       <p:sp>
         <p:nvSpPr>
-          <p:cNvPr id="12" name="Text 8"/>
+          <p:cNvPr id="16" name="Text 12"/>
           <p:cNvSpPr/>
           <p:nvPr/>
         </p:nvSpPr>
@@ -2165,7 +2362,7 @@
       </p:sp>
       <p:sp>
         <p:nvSpPr>
-          <p:cNvPr id="13" name="Text 9"/>
+          <p:cNvPr id="17" name="Text 13"/>
           <p:cNvSpPr/>
           <p:nvPr/>
         </p:nvSpPr>
@@ -2204,7 +2401,7 @@
       </p:sp>
       <p:sp>
         <p:nvSpPr>
-          <p:cNvPr id="14" name="Shape 10"/>
+          <p:cNvPr id="18" name="Shape 14"/>
           <p:cNvSpPr/>
           <p:nvPr/>
         </p:nvSpPr>
@@ -2233,7 +2430,7 @@
       </p:sp>
       <p:sp>
         <p:nvSpPr>
-          <p:cNvPr id="15" name="Shape 11"/>
+          <p:cNvPr id="19" name="Shape 15"/>
           <p:cNvSpPr/>
           <p:nvPr/>
         </p:nvSpPr>
@@ -2246,14 +2443,14 @@
             <a:avLst/>
           </a:prstGeom>
           <a:solidFill>
-            <a:srgbClr val="2F3C7E"/>
+            <a:srgbClr val="94268F"/>
           </a:solidFill>
           <a:ln/>
         </p:spPr>
       </p:sp>
       <p:pic>
         <p:nvPicPr>
-          <p:cNvPr id="16" name="Image 2" descr="preencoded.png">    </p:cNvPr>
+          <p:cNvPr id="20" name="Image 2" descr="preencoded.png">    </p:cNvPr>
           <p:cNvPicPr>
             <a:picLocks noChangeAspect="1"/>
           </p:cNvPicPr>
@@ -2277,7 +2474,7 @@
       </p:pic>
       <p:sp>
         <p:nvSpPr>
-          <p:cNvPr id="17" name="Text 12"/>
+          <p:cNvPr id="21" name="Text 16"/>
           <p:cNvSpPr/>
           <p:nvPr/>
         </p:nvSpPr>
@@ -2316,7 +2513,7 @@
       </p:sp>
       <p:sp>
         <p:nvSpPr>
-          <p:cNvPr id="18" name="Text 13"/>
+          <p:cNvPr id="22" name="Text 17"/>
           <p:cNvSpPr/>
           <p:nvPr/>
         </p:nvSpPr>
@@ -2387,7 +2584,87 @@
       </p:grpSpPr>
       <p:sp>
         <p:nvSpPr>
-          <p:cNvPr id="2" name="Text 0"/>
+          <p:cNvPr id="2" name="Shape 0"/>
+          <p:cNvSpPr/>
+          <p:nvPr/>
+        </p:nvSpPr>
+        <p:spPr>
+          <a:xfrm>
+            <a:off x="11612880" y="365760"/>
+            <a:ext cx="256032" cy="256032"/>
+          </a:xfrm>
+          <a:prstGeom prst="ellipse">
+            <a:avLst/>
+          </a:prstGeom>
+          <a:solidFill>
+            <a:srgbClr val="F9931D"/>
+          </a:solidFill>
+          <a:ln/>
+        </p:spPr>
+      </p:sp>
+      <p:sp>
+        <p:nvSpPr>
+          <p:cNvPr id="3" name="Shape 1"/>
+          <p:cNvSpPr/>
+          <p:nvPr/>
+        </p:nvSpPr>
+        <p:spPr>
+          <a:xfrm>
+            <a:off x="384048" y="5989320"/>
+            <a:ext cx="201168" cy="201168"/>
+          </a:xfrm>
+          <a:prstGeom prst="ellipse">
+            <a:avLst/>
+          </a:prstGeom>
+          <a:solidFill>
+            <a:srgbClr val="45B84B"/>
+          </a:solidFill>
+          <a:ln/>
+        </p:spPr>
+      </p:sp>
+      <p:sp>
+        <p:nvSpPr>
+          <p:cNvPr id="4" name="Shape 2"/>
+          <p:cNvSpPr/>
+          <p:nvPr/>
+        </p:nvSpPr>
+        <p:spPr>
+          <a:xfrm>
+            <a:off x="11109960" y="6126480"/>
+            <a:ext cx="274320" cy="274320"/>
+          </a:xfrm>
+          <a:prstGeom prst="ellipse">
+            <a:avLst/>
+          </a:prstGeom>
+          <a:solidFill>
+            <a:srgbClr val="94268F"/>
+          </a:solidFill>
+          <a:ln/>
+        </p:spPr>
+      </p:sp>
+      <p:sp>
+        <p:nvSpPr>
+          <p:cNvPr id="5" name="Shape 3"/>
+          <p:cNvSpPr/>
+          <p:nvPr/>
+        </p:nvSpPr>
+        <p:spPr>
+          <a:xfrm>
+            <a:off x="822960" y="6382512"/>
+            <a:ext cx="182880" cy="182880"/>
+          </a:xfrm>
+          <a:prstGeom prst="ellipse">
+            <a:avLst/>
+          </a:prstGeom>
+          <a:solidFill>
+            <a:srgbClr val="6CDBFE"/>
+          </a:solidFill>
+          <a:ln/>
+        </p:spPr>
+      </p:sp>
+      <p:sp>
+        <p:nvSpPr>
+          <p:cNvPr id="6" name="Text 4"/>
           <p:cNvSpPr/>
           <p:nvPr/>
         </p:nvSpPr>
@@ -2426,7 +2703,7 @@
       </p:sp>
       <p:sp>
         <p:nvSpPr>
-          <p:cNvPr id="3" name="Shape 1"/>
+          <p:cNvPr id="7" name="Shape 5"/>
           <p:cNvSpPr/>
           <p:nvPr/>
         </p:nvSpPr>
@@ -2455,7 +2732,7 @@
       </p:sp>
       <p:sp>
         <p:nvSpPr>
-          <p:cNvPr id="4" name="Shape 2"/>
+          <p:cNvPr id="8" name="Shape 6"/>
           <p:cNvSpPr/>
           <p:nvPr/>
         </p:nvSpPr>
@@ -2468,14 +2745,14 @@
             <a:avLst/>
           </a:prstGeom>
           <a:solidFill>
-            <a:srgbClr val="F96167"/>
-          </a:solidFill>
-          <a:ln/>
-        </p:spPr>
-      </p:sp>
-      <p:sp>
-        <p:nvSpPr>
-          <p:cNvPr id="5" name="Text 3"/>
+            <a:srgbClr val="F9931D"/>
+          </a:solidFill>
+          <a:ln/>
+        </p:spPr>
+      </p:sp>
+      <p:sp>
+        <p:nvSpPr>
+          <p:cNvPr id="9" name="Text 7"/>
           <p:cNvSpPr/>
           <p:nvPr/>
         </p:nvSpPr>
@@ -2514,7 +2791,7 @@
       </p:sp>
       <p:sp>
         <p:nvSpPr>
-          <p:cNvPr id="6" name="Text 4"/>
+          <p:cNvPr id="10" name="Text 8"/>
           <p:cNvSpPr/>
           <p:nvPr/>
         </p:nvSpPr>
@@ -2553,7 +2830,7 @@
       </p:sp>
       <p:sp>
         <p:nvSpPr>
-          <p:cNvPr id="7" name="Text 5"/>
+          <p:cNvPr id="11" name="Text 9"/>
           <p:cNvSpPr/>
           <p:nvPr/>
         </p:nvSpPr>
@@ -2592,7 +2869,7 @@
       </p:sp>
       <p:sp>
         <p:nvSpPr>
-          <p:cNvPr id="8" name="Shape 6"/>
+          <p:cNvPr id="12" name="Shape 10"/>
           <p:cNvSpPr/>
           <p:nvPr/>
         </p:nvSpPr>
@@ -2621,7 +2898,7 @@
       </p:sp>
       <p:sp>
         <p:nvSpPr>
-          <p:cNvPr id="9" name="Shape 7"/>
+          <p:cNvPr id="13" name="Shape 11"/>
           <p:cNvSpPr/>
           <p:nvPr/>
         </p:nvSpPr>
@@ -2634,14 +2911,14 @@
             <a:avLst/>
           </a:prstGeom>
           <a:solidFill>
-            <a:srgbClr val="F96167"/>
-          </a:solidFill>
-          <a:ln/>
-        </p:spPr>
-      </p:sp>
-      <p:sp>
-        <p:nvSpPr>
-          <p:cNvPr id="10" name="Text 8"/>
+            <a:srgbClr val="45B84B"/>
+          </a:solidFill>
+          <a:ln/>
+        </p:spPr>
+      </p:sp>
+      <p:sp>
+        <p:nvSpPr>
+          <p:cNvPr id="14" name="Text 12"/>
           <p:cNvSpPr/>
           <p:nvPr/>
         </p:nvSpPr>
@@ -2680,7 +2957,7 @@
       </p:sp>
       <p:sp>
         <p:nvSpPr>
-          <p:cNvPr id="11" name="Text 9"/>
+          <p:cNvPr id="15" name="Text 13"/>
           <p:cNvSpPr/>
           <p:nvPr/>
         </p:nvSpPr>
@@ -2719,7 +2996,7 @@
       </p:sp>
       <p:sp>
         <p:nvSpPr>
-          <p:cNvPr id="12" name="Text 10"/>
+          <p:cNvPr id="16" name="Text 14"/>
           <p:cNvSpPr/>
           <p:nvPr/>
         </p:nvSpPr>
@@ -2758,7 +3035,7 @@
       </p:sp>
       <p:sp>
         <p:nvSpPr>
-          <p:cNvPr id="13" name="Shape 11"/>
+          <p:cNvPr id="17" name="Shape 15"/>
           <p:cNvSpPr/>
           <p:nvPr/>
         </p:nvSpPr>
@@ -2787,7 +3064,7 @@
       </p:sp>
       <p:sp>
         <p:nvSpPr>
-          <p:cNvPr id="14" name="Shape 12"/>
+          <p:cNvPr id="18" name="Shape 16"/>
           <p:cNvSpPr/>
           <p:nvPr/>
         </p:nvSpPr>
@@ -2800,14 +3077,14 @@
             <a:avLst/>
           </a:prstGeom>
           <a:solidFill>
-            <a:srgbClr val="F96167"/>
-          </a:solidFill>
-          <a:ln/>
-        </p:spPr>
-      </p:sp>
-      <p:sp>
-        <p:nvSpPr>
-          <p:cNvPr id="15" name="Text 13"/>
+            <a:srgbClr val="2BA8E0"/>
+          </a:solidFill>
+          <a:ln/>
+        </p:spPr>
+      </p:sp>
+      <p:sp>
+        <p:nvSpPr>
+          <p:cNvPr id="19" name="Text 17"/>
           <p:cNvSpPr/>
           <p:nvPr/>
         </p:nvSpPr>
@@ -2846,7 +3123,7 @@
       </p:sp>
       <p:sp>
         <p:nvSpPr>
-          <p:cNvPr id="16" name="Text 14"/>
+          <p:cNvPr id="20" name="Text 18"/>
           <p:cNvSpPr/>
           <p:nvPr/>
         </p:nvSpPr>
@@ -2885,7 +3162,7 @@
       </p:sp>
       <p:sp>
         <p:nvSpPr>
-          <p:cNvPr id="17" name="Text 15"/>
+          <p:cNvPr id="21" name="Text 19"/>
           <p:cNvSpPr/>
           <p:nvPr/>
         </p:nvSpPr>
@@ -2924,7 +3201,7 @@
       </p:sp>
       <p:sp>
         <p:nvSpPr>
-          <p:cNvPr id="18" name="Shape 16"/>
+          <p:cNvPr id="22" name="Shape 20"/>
           <p:cNvSpPr/>
           <p:nvPr/>
         </p:nvSpPr>
@@ -2939,7 +3216,7 @@
             </a:avLst>
           </a:prstGeom>
           <a:solidFill>
-            <a:srgbClr val="2F3C7E"/>
+            <a:srgbClr val="94268F"/>
           </a:solidFill>
           <a:ln/>
           <a:effectLst>
@@ -2953,7 +3230,7 @@
       </p:sp>
       <p:sp>
         <p:nvSpPr>
-          <p:cNvPr id="19" name="Shape 17"/>
+          <p:cNvPr id="23" name="Shape 21"/>
           <p:cNvSpPr/>
           <p:nvPr/>
         </p:nvSpPr>
@@ -2973,7 +3250,7 @@
       </p:sp>
       <p:sp>
         <p:nvSpPr>
-          <p:cNvPr id="20" name="Text 18"/>
+          <p:cNvPr id="24" name="Text 22"/>
           <p:cNvSpPr/>
           <p:nvPr/>
         </p:nvSpPr>
@@ -2998,7 +3275,7 @@
             <a:r>
               <a:rPr lang="en-US" sz="2000" b="1" dirty="0">
                 <a:solidFill>
-                  <a:srgbClr val="2F3C7E"/>
+                  <a:srgbClr val="94268F"/>
                 </a:solidFill>
                 <a:latin typeface="Cambria" pitchFamily="34" charset="0"/>
                 <a:ea typeface="Cambria" pitchFamily="34" charset="-122"/>
@@ -3012,7 +3289,7 @@
       </p:sp>
       <p:sp>
         <p:nvSpPr>
-          <p:cNvPr id="21" name="Text 19"/>
+          <p:cNvPr id="25" name="Text 23"/>
           <p:cNvSpPr/>
           <p:nvPr/>
         </p:nvSpPr>
@@ -3051,7 +3328,7 @@
       </p:sp>
       <p:sp>
         <p:nvSpPr>
-          <p:cNvPr id="22" name="Text 20"/>
+          <p:cNvPr id="26" name="Text 24"/>
           <p:cNvSpPr/>
           <p:nvPr/>
         </p:nvSpPr>
@@ -3076,7 +3353,7 @@
             <a:r>
               <a:rPr lang="en-US" sz="1200" dirty="0">
                 <a:solidFill>
-                  <a:srgbClr val="DDE1F2"/>
+                  <a:srgbClr val="F2DDF0"/>
                 </a:solidFill>
                 <a:latin typeface="Calibri" pitchFamily="34" charset="0"/>
                 <a:ea typeface="Calibri" pitchFamily="34" charset="-122"/>
@@ -3264,7 +3541,7 @@
             <a:avLst/>
           </a:prstGeom>
           <a:solidFill>
-            <a:srgbClr val="F96167"/>
+            <a:srgbClr val="F9931D"/>
           </a:solidFill>
           <a:ln/>
         </p:spPr>
@@ -3376,7 +3653,7 @@
             <a:avLst/>
           </a:prstGeom>
           <a:solidFill>
-            <a:srgbClr val="F96167"/>
+            <a:srgbClr val="45B84B"/>
           </a:solidFill>
           <a:ln/>
         </p:spPr>
@@ -3488,7 +3765,7 @@
             <a:avLst/>
           </a:prstGeom>
           <a:solidFill>
-            <a:srgbClr val="F96167"/>
+            <a:srgbClr val="2BA8E0"/>
           </a:solidFill>
           <a:ln/>
         </p:spPr>
@@ -3600,7 +3877,7 @@
             <a:avLst/>
           </a:prstGeom>
           <a:solidFill>
-            <a:srgbClr val="F96167"/>
+            <a:srgbClr val="94268F"/>
           </a:solidFill>
           <a:ln/>
         </p:spPr>
@@ -3702,7 +3979,87 @@
       </p:grpSpPr>
       <p:sp>
         <p:nvSpPr>
-          <p:cNvPr id="2" name="Text 0"/>
+          <p:cNvPr id="2" name="Shape 0"/>
+          <p:cNvSpPr/>
+          <p:nvPr/>
+        </p:nvSpPr>
+        <p:spPr>
+          <a:xfrm>
+            <a:off x="11612880" y="365760"/>
+            <a:ext cx="256032" cy="256032"/>
+          </a:xfrm>
+          <a:prstGeom prst="ellipse">
+            <a:avLst/>
+          </a:prstGeom>
+          <a:solidFill>
+            <a:srgbClr val="F9931D"/>
+          </a:solidFill>
+          <a:ln/>
+        </p:spPr>
+      </p:sp>
+      <p:sp>
+        <p:nvSpPr>
+          <p:cNvPr id="3" name="Shape 1"/>
+          <p:cNvSpPr/>
+          <p:nvPr/>
+        </p:nvSpPr>
+        <p:spPr>
+          <a:xfrm>
+            <a:off x="384048" y="5989320"/>
+            <a:ext cx="201168" cy="201168"/>
+          </a:xfrm>
+          <a:prstGeom prst="ellipse">
+            <a:avLst/>
+          </a:prstGeom>
+          <a:solidFill>
+            <a:srgbClr val="45B84B"/>
+          </a:solidFill>
+          <a:ln/>
+        </p:spPr>
+      </p:sp>
+      <p:sp>
+        <p:nvSpPr>
+          <p:cNvPr id="4" name="Shape 2"/>
+          <p:cNvSpPr/>
+          <p:nvPr/>
+        </p:nvSpPr>
+        <p:spPr>
+          <a:xfrm>
+            <a:off x="11109960" y="6126480"/>
+            <a:ext cx="274320" cy="274320"/>
+          </a:xfrm>
+          <a:prstGeom prst="ellipse">
+            <a:avLst/>
+          </a:prstGeom>
+          <a:solidFill>
+            <a:srgbClr val="94268F"/>
+          </a:solidFill>
+          <a:ln/>
+        </p:spPr>
+      </p:sp>
+      <p:sp>
+        <p:nvSpPr>
+          <p:cNvPr id="5" name="Shape 3"/>
+          <p:cNvSpPr/>
+          <p:nvPr/>
+        </p:nvSpPr>
+        <p:spPr>
+          <a:xfrm>
+            <a:off x="822960" y="6382512"/>
+            <a:ext cx="182880" cy="182880"/>
+          </a:xfrm>
+          <a:prstGeom prst="ellipse">
+            <a:avLst/>
+          </a:prstGeom>
+          <a:solidFill>
+            <a:srgbClr val="6CDBFE"/>
+          </a:solidFill>
+          <a:ln/>
+        </p:spPr>
+      </p:sp>
+      <p:sp>
+        <p:nvSpPr>
+          <p:cNvPr id="6" name="Text 4"/>
           <p:cNvSpPr/>
           <p:nvPr/>
         </p:nvSpPr>
@@ -3741,7 +4098,7 @@
       </p:sp>
       <p:sp>
         <p:nvSpPr>
-          <p:cNvPr id="3" name="Text 1"/>
+          <p:cNvPr id="7" name="Text 5"/>
           <p:cNvSpPr/>
           <p:nvPr/>
         </p:nvSpPr>
@@ -3780,7 +4137,7 @@
       </p:sp>
       <p:sp>
         <p:nvSpPr>
-          <p:cNvPr id="4" name="Shape 2"/>
+          <p:cNvPr id="8" name="Shape 6"/>
           <p:cNvSpPr/>
           <p:nvPr/>
         </p:nvSpPr>
@@ -3809,7 +4166,7 @@
       </p:sp>
       <p:sp>
         <p:nvSpPr>
-          <p:cNvPr id="5" name="Shape 3"/>
+          <p:cNvPr id="9" name="Shape 7"/>
           <p:cNvSpPr/>
           <p:nvPr/>
         </p:nvSpPr>
@@ -3822,14 +4179,14 @@
             <a:avLst/>
           </a:prstGeom>
           <a:solidFill>
-            <a:srgbClr val="F96167"/>
+            <a:srgbClr val="F9931D"/>
           </a:solidFill>
           <a:ln/>
         </p:spPr>
       </p:sp>
       <p:pic>
         <p:nvPicPr>
-          <p:cNvPr id="6" name="Image 0" descr="preencoded.png">    </p:cNvPr>
+          <p:cNvPr id="10" name="Image 0" descr="preencoded.png">    </p:cNvPr>
           <p:cNvPicPr>
             <a:picLocks noChangeAspect="1"/>
           </p:cNvPicPr>
@@ -3853,7 +4210,7 @@
       </p:pic>
       <p:sp>
         <p:nvSpPr>
-          <p:cNvPr id="7" name="Text 4"/>
+          <p:cNvPr id="11" name="Text 8"/>
           <p:cNvSpPr/>
           <p:nvPr/>
         </p:nvSpPr>
@@ -3892,7 +4249,7 @@
       </p:sp>
       <p:sp>
         <p:nvSpPr>
-          <p:cNvPr id="8" name="Text 5"/>
+          <p:cNvPr id="12" name="Text 9"/>
           <p:cNvSpPr/>
           <p:nvPr/>
         </p:nvSpPr>
@@ -3931,7 +4288,7 @@
       </p:sp>
       <p:sp>
         <p:nvSpPr>
-          <p:cNvPr id="9" name="Shape 6"/>
+          <p:cNvPr id="13" name="Shape 10"/>
           <p:cNvSpPr/>
           <p:nvPr/>
         </p:nvSpPr>
@@ -3960,7 +4317,7 @@
       </p:sp>
       <p:sp>
         <p:nvSpPr>
-          <p:cNvPr id="10" name="Shape 7"/>
+          <p:cNvPr id="14" name="Shape 11"/>
           <p:cNvSpPr/>
           <p:nvPr/>
         </p:nvSpPr>
@@ -3973,14 +4330,14 @@
             <a:avLst/>
           </a:prstGeom>
           <a:solidFill>
-            <a:srgbClr val="2F3C7E"/>
+            <a:srgbClr val="94268F"/>
           </a:solidFill>
           <a:ln/>
         </p:spPr>
       </p:sp>
       <p:pic>
         <p:nvPicPr>
-          <p:cNvPr id="11" name="Image 1" descr="preencoded.png">    </p:cNvPr>
+          <p:cNvPr id="15" name="Image 1" descr="preencoded.png">    </p:cNvPr>
           <p:cNvPicPr>
             <a:picLocks noChangeAspect="1"/>
           </p:cNvPicPr>
@@ -4004,7 +4361,7 @@
       </p:pic>
       <p:sp>
         <p:nvSpPr>
-          <p:cNvPr id="12" name="Text 8"/>
+          <p:cNvPr id="16" name="Text 12"/>
           <p:cNvSpPr/>
           <p:nvPr/>
         </p:nvSpPr>
@@ -4043,7 +4400,7 @@
       </p:sp>
       <p:sp>
         <p:nvSpPr>
-          <p:cNvPr id="13" name="Text 9"/>
+          <p:cNvPr id="17" name="Text 13"/>
           <p:cNvSpPr/>
           <p:nvPr/>
         </p:nvSpPr>
@@ -4082,7 +4439,7 @@
       </p:sp>
       <p:sp>
         <p:nvSpPr>
-          <p:cNvPr id="14" name="Shape 10"/>
+          <p:cNvPr id="18" name="Shape 14"/>
           <p:cNvSpPr/>
           <p:nvPr/>
         </p:nvSpPr>
@@ -4111,7 +4468,7 @@
       </p:sp>
       <p:sp>
         <p:nvSpPr>
-          <p:cNvPr id="15" name="Shape 11"/>
+          <p:cNvPr id="19" name="Shape 15"/>
           <p:cNvSpPr/>
           <p:nvPr/>
         </p:nvSpPr>
@@ -4124,14 +4481,14 @@
             <a:avLst/>
           </a:prstGeom>
           <a:solidFill>
-            <a:srgbClr val="F96167"/>
+            <a:srgbClr val="45B84B"/>
           </a:solidFill>
           <a:ln/>
         </p:spPr>
       </p:sp>
       <p:pic>
         <p:nvPicPr>
-          <p:cNvPr id="16" name="Image 2" descr="preencoded.png">    </p:cNvPr>
+          <p:cNvPr id="20" name="Image 2" descr="preencoded.png">    </p:cNvPr>
           <p:cNvPicPr>
             <a:picLocks noChangeAspect="1"/>
           </p:cNvPicPr>
@@ -4155,7 +4512,7 @@
       </p:pic>
       <p:sp>
         <p:nvSpPr>
-          <p:cNvPr id="17" name="Text 12"/>
+          <p:cNvPr id="21" name="Text 16"/>
           <p:cNvSpPr/>
           <p:nvPr/>
         </p:nvSpPr>
@@ -4194,7 +4551,7 @@
       </p:sp>
       <p:sp>
         <p:nvSpPr>
-          <p:cNvPr id="18" name="Text 13"/>
+          <p:cNvPr id="22" name="Text 17"/>
           <p:cNvSpPr/>
           <p:nvPr/>
         </p:nvSpPr>
@@ -4296,64 +4653,15 @@
                 <a:ea typeface="Cambria" pitchFamily="34" charset="-122"/>
                 <a:cs typeface="Cambria" pitchFamily="34" charset="-120"/>
               </a:rPr>
-              <a:t>Au-delà des campagnes</a:t>
+              <a:t>Nos actions en images</a:t>
             </a:r>
             <a:endParaRPr lang="en-US" sz="3800" dirty="0"/>
           </a:p>
         </p:txBody>
-      </p:sp>
-      <p:sp>
-        <p:nvSpPr>
-          <p:cNvPr id="3" name="Shape 1"/>
-          <p:cNvSpPr/>
-          <p:nvPr/>
-        </p:nvSpPr>
-        <p:spPr>
-          <a:xfrm>
-            <a:off x="640080" y="1645920"/>
-            <a:ext cx="5349240" cy="4023360"/>
-          </a:xfrm>
-          <a:prstGeom prst="roundRect">
-            <a:avLst>
-              <a:gd name="adj" fmla="val 2727"/>
-            </a:avLst>
-          </a:prstGeom>
-          <a:solidFill>
-            <a:srgbClr val="F4F5FA"/>
-          </a:solidFill>
-          <a:ln/>
-          <a:effectLst>
-            <a:outerShdw sx="100000" sy="100000" kx="0" ky="0" algn="bl" rotWithShape="0" blurRad="76200" dist="25400" dir="5400000">
-              <a:srgbClr val="AAAAAA">
-                <a:alpha val="30000"/>
-              </a:srgbClr>
-            </a:outerShdw>
-          </a:effectLst>
-        </p:spPr>
-      </p:sp>
-      <p:sp>
-        <p:nvSpPr>
-          <p:cNvPr id="4" name="Shape 2"/>
-          <p:cNvSpPr/>
-          <p:nvPr/>
-        </p:nvSpPr>
-        <p:spPr>
-          <a:xfrm>
-            <a:off x="1051560" y="2057400"/>
-            <a:ext cx="960120" cy="960120"/>
-          </a:xfrm>
-          <a:prstGeom prst="ellipse">
-            <a:avLst/>
-          </a:prstGeom>
-          <a:solidFill>
-            <a:srgbClr val="2F3C7E"/>
-          </a:solidFill>
-          <a:ln/>
-        </p:spPr>
       </p:sp>
       <p:pic>
         <p:nvPicPr>
-          <p:cNvPr id="5" name="Image 0" descr="preencoded.png">    </p:cNvPr>
+          <p:cNvPr id="3" name="Image 0" descr="preencoded.png">    </p:cNvPr>
           <p:cNvPicPr>
             <a:picLocks noChangeAspect="1"/>
           </p:cNvPicPr>
@@ -4367,46 +4675,31 @@
         </p:blipFill>
         <p:spPr>
           <a:xfrm>
-            <a:off x="1301191" y="2307031"/>
-            <a:ext cx="460858" cy="460858"/>
-          </a:xfrm>
-          <a:prstGeom prst="rect">
-            <a:avLst/>
-          </a:prstGeom>
+            <a:off x="640080" y="1417320"/>
+            <a:ext cx="6720840" cy="4469359"/>
+          </a:xfrm>
+          <a:prstGeom prst="rect">
+            <a:avLst/>
+          </a:prstGeom>
+          <a:effectLst>
+            <a:outerShdw sx="100000" sy="100000" kx="0" ky="0" algn="bl" rotWithShape="0" blurRad="101600" dist="38100" dir="5400000">
+              <a:srgbClr val="888888">
+                <a:alpha val="40000"/>
+              </a:srgbClr>
+            </a:outerShdw>
+          </a:effectLst>
         </p:spPr>
       </p:pic>
       <p:sp>
         <p:nvSpPr>
-          <p:cNvPr id="6" name="Shape 3"/>
-          <p:cNvSpPr/>
-          <p:nvPr/>
-        </p:nvSpPr>
-        <p:spPr>
-          <a:xfrm>
-            <a:off x="3611880" y="2194560"/>
-            <a:ext cx="2011680" cy="457200"/>
-          </a:xfrm>
-          <a:prstGeom prst="roundRect">
-            <a:avLst>
-              <a:gd name="adj" fmla="val 50000"/>
-            </a:avLst>
-          </a:prstGeom>
-          <a:solidFill>
-            <a:srgbClr val="2F3C7E"/>
-          </a:solidFill>
-          <a:ln/>
-        </p:spPr>
-      </p:sp>
-      <p:sp>
-        <p:nvSpPr>
-          <p:cNvPr id="7" name="Text 4"/>
-          <p:cNvSpPr/>
-          <p:nvPr/>
-        </p:nvSpPr>
-        <p:spPr>
-          <a:xfrm>
-            <a:off x="3611880" y="2194560"/>
-            <a:ext cx="2011680" cy="457200"/>
+          <p:cNvPr id="4" name="Text 1"/>
+          <p:cNvSpPr/>
+          <p:nvPr/>
+        </p:nvSpPr>
+        <p:spPr>
+          <a:xfrm>
+            <a:off x="640080" y="5996407"/>
+            <a:ext cx="6720840" cy="365760"/>
           </a:xfrm>
           <a:prstGeom prst="rect">
             <a:avLst/>
@@ -4415,157 +4708,30 @@
           <a:ln/>
         </p:spPr>
         <p:txBody>
-          <a:bodyPr wrap="square" lIns="0" tIns="0" rIns="0" bIns="0" rtlCol="0" anchor="ctr"/>
+          <a:bodyPr wrap="square" rtlCol="0" anchor="ctr"/>
           <a:lstStyle/>
           <a:p>
             <a:pPr algn="ctr" indent="0" marL="0">
               <a:buNone/>
             </a:pPr>
             <a:r>
-              <a:rPr lang="en-US" sz="1100" b="1" dirty="0">
-                <a:solidFill>
-                  <a:srgbClr val="FFFFFF"/>
+              <a:rPr lang="en-US" sz="1200" i="1" dirty="0">
+                <a:solidFill>
+                  <a:srgbClr val="5A5A6E"/>
                 </a:solidFill>
                 <a:latin typeface="Calibri" pitchFamily="34" charset="0"/>
                 <a:ea typeface="Calibri" pitchFamily="34" charset="-122"/>
                 <a:cs typeface="Calibri" pitchFamily="34" charset="-120"/>
               </a:rPr>
-              <a:t>Au Bénin</a:t>
-            </a:r>
-            <a:endParaRPr lang="en-US" sz="1100" dirty="0"/>
-          </a:p>
-        </p:txBody>
-      </p:sp>
-      <p:sp>
-        <p:nvSpPr>
-          <p:cNvPr id="8" name="Text 5"/>
-          <p:cNvSpPr/>
-          <p:nvPr/>
-        </p:nvSpPr>
-        <p:spPr>
-          <a:xfrm>
-            <a:off x="1051560" y="3291840"/>
-            <a:ext cx="4526280" cy="822960"/>
-          </a:xfrm>
-          <a:prstGeom prst="rect">
-            <a:avLst/>
-          </a:prstGeom>
-          <a:noFill/>
-          <a:ln/>
-        </p:spPr>
-        <p:txBody>
-          <a:bodyPr wrap="square" lIns="0" tIns="0" rIns="0" bIns="0" rtlCol="0" anchor="ctr"/>
-          <a:lstStyle/>
-          <a:p>
-            <a:pPr indent="0" marL="0">
-              <a:buNone/>
-            </a:pPr>
-            <a:r>
-              <a:rPr lang="en-US" sz="2100" b="1" dirty="0">
-                <a:solidFill>
-                  <a:srgbClr val="2F3C7E"/>
-                </a:solidFill>
-                <a:latin typeface="Cambria" pitchFamily="34" charset="0"/>
-                <a:ea typeface="Cambria" pitchFamily="34" charset="-122"/>
-                <a:cs typeface="Cambria" pitchFamily="34" charset="-120"/>
-              </a:rPr>
-              <a:t>Les familles en grande difficulté</a:t>
-            </a:r>
-            <a:endParaRPr lang="en-US" sz="2100" dirty="0"/>
-          </a:p>
-        </p:txBody>
-      </p:sp>
-      <p:sp>
-        <p:nvSpPr>
-          <p:cNvPr id="9" name="Text 6"/>
-          <p:cNvSpPr/>
-          <p:nvPr/>
-        </p:nvSpPr>
-        <p:spPr>
-          <a:xfrm>
-            <a:off x="1051560" y="4160520"/>
-            <a:ext cx="4526280" cy="1371600"/>
-          </a:xfrm>
-          <a:prstGeom prst="rect">
-            <a:avLst/>
-          </a:prstGeom>
-          <a:noFill/>
-          <a:ln/>
-        </p:spPr>
-        <p:txBody>
-          <a:bodyPr wrap="square" lIns="0" tIns="0" rIns="0" bIns="0" rtlCol="0" anchor="t"/>
-          <a:lstStyle/>
-          <a:p>
-            <a:pPr indent="0" marL="0">
-              <a:buNone/>
-            </a:pPr>
-            <a:r>
-              <a:rPr lang="en-US" sz="1400" dirty="0">
-                <a:solidFill>
-                  <a:srgbClr val="444444"/>
-                </a:solidFill>
-                <a:latin typeface="Calibri" pitchFamily="34" charset="0"/>
-                <a:ea typeface="Calibri" pitchFamily="34" charset="-122"/>
-                <a:cs typeface="Calibri" pitchFamily="34" charset="-120"/>
-              </a:rPr>
-              <a:t>Nous apportons une aide adaptée à leurs besoins essentiels : alimentation, vêtements, soutien matériel.</a:t>
-            </a:r>
-            <a:endParaRPr lang="en-US" sz="1400" dirty="0"/>
-          </a:p>
-        </p:txBody>
-      </p:sp>
-      <p:sp>
-        <p:nvSpPr>
-          <p:cNvPr id="10" name="Shape 7"/>
-          <p:cNvSpPr/>
-          <p:nvPr/>
-        </p:nvSpPr>
-        <p:spPr>
-          <a:xfrm>
-            <a:off x="6199632" y="1645920"/>
-            <a:ext cx="5349240" cy="4023360"/>
-          </a:xfrm>
-          <a:prstGeom prst="roundRect">
-            <a:avLst>
-              <a:gd name="adj" fmla="val 2727"/>
-            </a:avLst>
-          </a:prstGeom>
-          <a:solidFill>
-            <a:srgbClr val="F4F5FA"/>
-          </a:solidFill>
-          <a:ln/>
-          <a:effectLst>
-            <a:outerShdw sx="100000" sy="100000" kx="0" ky="0" algn="bl" rotWithShape="0" blurRad="76200" dist="25400" dir="5400000">
-              <a:srgbClr val="AAAAAA">
-                <a:alpha val="30000"/>
-              </a:srgbClr>
-            </a:outerShdw>
-          </a:effectLst>
-        </p:spPr>
-      </p:sp>
-      <p:sp>
-        <p:nvSpPr>
-          <p:cNvPr id="11" name="Shape 8"/>
-          <p:cNvSpPr/>
-          <p:nvPr/>
-        </p:nvSpPr>
-        <p:spPr>
-          <a:xfrm>
-            <a:off x="6611112" y="2057400"/>
-            <a:ext cx="960120" cy="960120"/>
-          </a:xfrm>
-          <a:prstGeom prst="ellipse">
-            <a:avLst/>
-          </a:prstGeom>
-          <a:solidFill>
-            <a:srgbClr val="F96167"/>
-          </a:solidFill>
-          <a:ln/>
-        </p:spPr>
+              <a:t>Remise de fournitures et de vivres dans un orphelinat au Bénin</a:t>
+            </a:r>
+            <a:endParaRPr lang="en-US" sz="1200" dirty="0"/>
+          </a:p>
+        </p:txBody>
       </p:sp>
       <p:pic>
         <p:nvPicPr>
-          <p:cNvPr id="12" name="Image 1" descr="preencoded.png">    </p:cNvPr>
+          <p:cNvPr id="5" name="Image 1" descr="preencoded.png">    </p:cNvPr>
           <p:cNvPicPr>
             <a:picLocks noChangeAspect="1"/>
           </p:cNvPicPr>
@@ -4579,46 +4745,62 @@
         </p:blipFill>
         <p:spPr>
           <a:xfrm>
-            <a:off x="6860743" y="2307031"/>
-            <a:ext cx="460858" cy="460858"/>
-          </a:xfrm>
-          <a:prstGeom prst="rect">
-            <a:avLst/>
-          </a:prstGeom>
+            <a:off x="7680960" y="1417320"/>
+            <a:ext cx="3749040" cy="2553096"/>
+          </a:xfrm>
+          <a:prstGeom prst="rect">
+            <a:avLst/>
+          </a:prstGeom>
+          <a:effectLst>
+            <a:outerShdw sx="100000" sy="100000" kx="0" ky="0" algn="bl" rotWithShape="0" blurRad="101600" dist="38100" dir="5400000">
+              <a:srgbClr val="888888">
+                <a:alpha val="40000"/>
+              </a:srgbClr>
+            </a:outerShdw>
+          </a:effectLst>
         </p:spPr>
       </p:pic>
-      <p:sp>
-        <p:nvSpPr>
-          <p:cNvPr id="13" name="Shape 9"/>
-          <p:cNvSpPr/>
-          <p:nvPr/>
-        </p:nvSpPr>
-        <p:spPr>
-          <a:xfrm>
-            <a:off x="9171432" y="2194560"/>
-            <a:ext cx="2011680" cy="457200"/>
-          </a:xfrm>
-          <a:prstGeom prst="roundRect">
-            <a:avLst>
-              <a:gd name="adj" fmla="val 50000"/>
-            </a:avLst>
-          </a:prstGeom>
-          <a:solidFill>
-            <a:srgbClr val="F96167"/>
-          </a:solidFill>
-          <a:ln/>
-        </p:spPr>
-      </p:sp>
-      <p:sp>
-        <p:nvSpPr>
-          <p:cNvPr id="14" name="Text 10"/>
-          <p:cNvSpPr/>
-          <p:nvPr/>
-        </p:nvSpPr>
-        <p:spPr>
-          <a:xfrm>
-            <a:off x="9171432" y="2194560"/>
-            <a:ext cx="2011680" cy="457200"/>
+      <p:pic>
+        <p:nvPicPr>
+          <p:cNvPr id="6" name="Image 2" descr="preencoded.png">    </p:cNvPr>
+          <p:cNvPicPr>
+            <a:picLocks noChangeAspect="1"/>
+          </p:cNvPicPr>
+          <p:nvPr/>
+        </p:nvPicPr>
+        <p:blipFill>
+          <a:blip r:embed="rId3"/>
+          <a:stretch>
+            <a:fillRect/>
+          </a:stretch>
+        </p:blipFill>
+        <p:spPr>
+          <a:xfrm>
+            <a:off x="7680960" y="4244736"/>
+            <a:ext cx="3749040" cy="2135078"/>
+          </a:xfrm>
+          <a:prstGeom prst="rect">
+            <a:avLst/>
+          </a:prstGeom>
+          <a:effectLst>
+            <a:outerShdw sx="100000" sy="100000" kx="0" ky="0" algn="bl" rotWithShape="0" blurRad="101600" dist="38100" dir="5400000">
+              <a:srgbClr val="888888">
+                <a:alpha val="40000"/>
+              </a:srgbClr>
+            </a:outerShdw>
+          </a:effectLst>
+        </p:spPr>
+      </p:pic>
+      <p:sp>
+        <p:nvSpPr>
+          <p:cNvPr id="7" name="Text 2"/>
+          <p:cNvSpPr/>
+          <p:nvPr/>
+        </p:nvSpPr>
+        <p:spPr>
+          <a:xfrm>
+            <a:off x="7680960" y="6452967"/>
+            <a:ext cx="3749040" cy="320040"/>
           </a:xfrm>
           <a:prstGeom prst="rect">
             <a:avLst/>
@@ -4627,102 +4809,24 @@
           <a:ln/>
         </p:spPr>
         <p:txBody>
-          <a:bodyPr wrap="square" lIns="0" tIns="0" rIns="0" bIns="0" rtlCol="0" anchor="ctr"/>
+          <a:bodyPr wrap="square" rtlCol="0" anchor="ctr"/>
           <a:lstStyle/>
           <a:p>
             <a:pPr algn="ctr" indent="0" marL="0">
               <a:buNone/>
             </a:pPr>
             <a:r>
-              <a:rPr lang="en-US" sz="1100" b="1" dirty="0">
-                <a:solidFill>
-                  <a:srgbClr val="FFFFFF"/>
+              <a:rPr lang="en-US" sz="1100" i="1" dirty="0">
+                <a:solidFill>
+                  <a:srgbClr val="5A5A6E"/>
                 </a:solidFill>
                 <a:latin typeface="Calibri" pitchFamily="34" charset="0"/>
                 <a:ea typeface="Calibri" pitchFamily="34" charset="-122"/>
                 <a:cs typeface="Calibri" pitchFamily="34" charset="-120"/>
               </a:rPr>
-              <a:t>En France — depuis 2024</a:t>
+              <a:t>Kits scolaires : cartables, cahiers, stylos…</a:t>
             </a:r>
             <a:endParaRPr lang="en-US" sz="1100" dirty="0"/>
-          </a:p>
-        </p:txBody>
-      </p:sp>
-      <p:sp>
-        <p:nvSpPr>
-          <p:cNvPr id="15" name="Text 11"/>
-          <p:cNvSpPr/>
-          <p:nvPr/>
-        </p:nvSpPr>
-        <p:spPr>
-          <a:xfrm>
-            <a:off x="6611112" y="3291840"/>
-            <a:ext cx="4526280" cy="822960"/>
-          </a:xfrm>
-          <a:prstGeom prst="rect">
-            <a:avLst/>
-          </a:prstGeom>
-          <a:noFill/>
-          <a:ln/>
-        </p:spPr>
-        <p:txBody>
-          <a:bodyPr wrap="square" lIns="0" tIns="0" rIns="0" bIns="0" rtlCol="0" anchor="ctr"/>
-          <a:lstStyle/>
-          <a:p>
-            <a:pPr indent="0" marL="0">
-              <a:buNone/>
-            </a:pPr>
-            <a:r>
-              <a:rPr lang="en-US" sz="2100" b="1" dirty="0">
-                <a:solidFill>
-                  <a:srgbClr val="2F3C7E"/>
-                </a:solidFill>
-                <a:latin typeface="Cambria" pitchFamily="34" charset="0"/>
-                <a:ea typeface="Cambria" pitchFamily="34" charset="-122"/>
-                <a:cs typeface="Cambria" pitchFamily="34" charset="-120"/>
-              </a:rPr>
-              <a:t>Les personnes sans abri</a:t>
-            </a:r>
-            <a:endParaRPr lang="en-US" sz="2100" dirty="0"/>
-          </a:p>
-        </p:txBody>
-      </p:sp>
-      <p:sp>
-        <p:nvSpPr>
-          <p:cNvPr id="16" name="Text 12"/>
-          <p:cNvSpPr/>
-          <p:nvPr/>
-        </p:nvSpPr>
-        <p:spPr>
-          <a:xfrm>
-            <a:off x="6611112" y="4160520"/>
-            <a:ext cx="4526280" cy="1371600"/>
-          </a:xfrm>
-          <a:prstGeom prst="rect">
-            <a:avLst/>
-          </a:prstGeom>
-          <a:noFill/>
-          <a:ln/>
-        </p:spPr>
-        <p:txBody>
-          <a:bodyPr wrap="square" lIns="0" tIns="0" rIns="0" bIns="0" rtlCol="0" anchor="t"/>
-          <a:lstStyle/>
-          <a:p>
-            <a:pPr indent="0" marL="0">
-              <a:buNone/>
-            </a:pPr>
-            <a:r>
-              <a:rPr lang="en-US" sz="1400" dirty="0">
-                <a:solidFill>
-                  <a:srgbClr val="444444"/>
-                </a:solidFill>
-                <a:latin typeface="Calibri" pitchFamily="34" charset="0"/>
-                <a:ea typeface="Calibri" pitchFamily="34" charset="-122"/>
-                <a:cs typeface="Calibri" pitchFamily="34" charset="-120"/>
-              </a:rPr>
-              <a:t>Depuis 2024, nous menons en France des distributions et des actions solidaires destinées à améliorer leur quotidien.</a:t>
-            </a:r>
-            <a:endParaRPr lang="en-US" sz="1400" dirty="0"/>
           </a:p>
         </p:txBody>
       </p:sp>
@@ -4760,7 +4864,87 @@
       </p:grpSpPr>
       <p:sp>
         <p:nvSpPr>
-          <p:cNvPr id="2" name="Text 0"/>
+          <p:cNvPr id="2" name="Shape 0"/>
+          <p:cNvSpPr/>
+          <p:nvPr/>
+        </p:nvSpPr>
+        <p:spPr>
+          <a:xfrm>
+            <a:off x="11612880" y="365760"/>
+            <a:ext cx="256032" cy="256032"/>
+          </a:xfrm>
+          <a:prstGeom prst="ellipse">
+            <a:avLst/>
+          </a:prstGeom>
+          <a:solidFill>
+            <a:srgbClr val="F9931D"/>
+          </a:solidFill>
+          <a:ln/>
+        </p:spPr>
+      </p:sp>
+      <p:sp>
+        <p:nvSpPr>
+          <p:cNvPr id="3" name="Shape 1"/>
+          <p:cNvSpPr/>
+          <p:nvPr/>
+        </p:nvSpPr>
+        <p:spPr>
+          <a:xfrm>
+            <a:off x="384048" y="5989320"/>
+            <a:ext cx="201168" cy="201168"/>
+          </a:xfrm>
+          <a:prstGeom prst="ellipse">
+            <a:avLst/>
+          </a:prstGeom>
+          <a:solidFill>
+            <a:srgbClr val="45B84B"/>
+          </a:solidFill>
+          <a:ln/>
+        </p:spPr>
+      </p:sp>
+      <p:sp>
+        <p:nvSpPr>
+          <p:cNvPr id="4" name="Shape 2"/>
+          <p:cNvSpPr/>
+          <p:nvPr/>
+        </p:nvSpPr>
+        <p:spPr>
+          <a:xfrm>
+            <a:off x="11109960" y="6126480"/>
+            <a:ext cx="274320" cy="274320"/>
+          </a:xfrm>
+          <a:prstGeom prst="ellipse">
+            <a:avLst/>
+          </a:prstGeom>
+          <a:solidFill>
+            <a:srgbClr val="94268F"/>
+          </a:solidFill>
+          <a:ln/>
+        </p:spPr>
+      </p:sp>
+      <p:sp>
+        <p:nvSpPr>
+          <p:cNvPr id="5" name="Shape 3"/>
+          <p:cNvSpPr/>
+          <p:nvPr/>
+        </p:nvSpPr>
+        <p:spPr>
+          <a:xfrm>
+            <a:off x="822960" y="6382512"/>
+            <a:ext cx="182880" cy="182880"/>
+          </a:xfrm>
+          <a:prstGeom prst="ellipse">
+            <a:avLst/>
+          </a:prstGeom>
+          <a:solidFill>
+            <a:srgbClr val="6CDBFE"/>
+          </a:solidFill>
+          <a:ln/>
+        </p:spPr>
+      </p:sp>
+      <p:sp>
+        <p:nvSpPr>
+          <p:cNvPr id="6" name="Text 4"/>
           <p:cNvSpPr/>
           <p:nvPr/>
         </p:nvSpPr>
@@ -4791,7 +4975,7 @@
                 <a:ea typeface="Cambria" pitchFamily="34" charset="-122"/>
                 <a:cs typeface="Cambria" pitchFamily="34" charset="-120"/>
               </a:rPr>
-              <a:t>Notre ambition</a:t>
+              <a:t>Au-delà des campagnes</a:t>
             </a:r>
             <a:endParaRPr lang="en-US" sz="3800" dirty="0"/>
           </a:p>
@@ -4799,66 +4983,56 @@
       </p:sp>
       <p:sp>
         <p:nvSpPr>
-          <p:cNvPr id="3" name="Text 1"/>
-          <p:cNvSpPr/>
-          <p:nvPr/>
-        </p:nvSpPr>
-        <p:spPr>
-          <a:xfrm>
-            <a:off x="640080" y="1188720"/>
-            <a:ext cx="10881360" cy="777240"/>
-          </a:xfrm>
-          <a:prstGeom prst="rect">
-            <a:avLst/>
-          </a:prstGeom>
-          <a:noFill/>
-          <a:ln/>
-        </p:spPr>
-        <p:txBody>
-          <a:bodyPr wrap="square" rtlCol="0" anchor="ctr"/>
-          <a:lstStyle/>
-          <a:p>
-            <a:pPr indent="0" marL="0">
-              <a:buNone/>
-            </a:pPr>
-            <a:r>
-              <a:rPr lang="en-US" sz="1500" i="1" dirty="0">
-                <a:solidFill>
-                  <a:srgbClr val="5A5A6E"/>
-                </a:solidFill>
-                <a:latin typeface="Calibri" pitchFamily="34" charset="0"/>
-                <a:ea typeface="Calibri" pitchFamily="34" charset="-122"/>
-                <a:cs typeface="Calibri" pitchFamily="34" charset="-120"/>
-              </a:rPr>
-              <a:t>Continuer à grandir pour aider plus d’enfants, soutenir plus de familles, et poursuivre nos actions auprès des personnes sans abri — avec des projets durables qui changent réellement les vies.</a:t>
-            </a:r>
-            <a:endParaRPr lang="en-US" sz="1500" dirty="0"/>
-          </a:p>
-        </p:txBody>
-      </p:sp>
-      <p:sp>
-        <p:nvSpPr>
-          <p:cNvPr id="4" name="Shape 2"/>
-          <p:cNvSpPr/>
-          <p:nvPr/>
-        </p:nvSpPr>
-        <p:spPr>
-          <a:xfrm>
-            <a:off x="822960" y="2148840"/>
-            <a:ext cx="914400" cy="914400"/>
+          <p:cNvPr id="7" name="Shape 5"/>
+          <p:cNvSpPr/>
+          <p:nvPr/>
+        </p:nvSpPr>
+        <p:spPr>
+          <a:xfrm>
+            <a:off x="640080" y="1645920"/>
+            <a:ext cx="5349240" cy="4023360"/>
+          </a:xfrm>
+          <a:prstGeom prst="roundRect">
+            <a:avLst>
+              <a:gd name="adj" fmla="val 2727"/>
+            </a:avLst>
+          </a:prstGeom>
+          <a:solidFill>
+            <a:srgbClr val="F4F5FA"/>
+          </a:solidFill>
+          <a:ln/>
+          <a:effectLst>
+            <a:outerShdw sx="100000" sy="100000" kx="0" ky="0" algn="bl" rotWithShape="0" blurRad="76200" dist="25400" dir="5400000">
+              <a:srgbClr val="AAAAAA">
+                <a:alpha val="30000"/>
+              </a:srgbClr>
+            </a:outerShdw>
+          </a:effectLst>
+        </p:spPr>
+      </p:sp>
+      <p:sp>
+        <p:nvSpPr>
+          <p:cNvPr id="8" name="Shape 6"/>
+          <p:cNvSpPr/>
+          <p:nvPr/>
+        </p:nvSpPr>
+        <p:spPr>
+          <a:xfrm>
+            <a:off x="1051560" y="2057400"/>
+            <a:ext cx="960120" cy="960120"/>
           </a:xfrm>
           <a:prstGeom prst="ellipse">
             <a:avLst/>
           </a:prstGeom>
           <a:solidFill>
-            <a:srgbClr val="2F3C7E"/>
+            <a:srgbClr val="45B84B"/>
           </a:solidFill>
           <a:ln/>
         </p:spPr>
       </p:sp>
       <p:pic>
         <p:nvPicPr>
-          <p:cNvPr id="5" name="Image 0" descr="preencoded.png">    </p:cNvPr>
+          <p:cNvPr id="9" name="Image 0" descr="preencoded.png">    </p:cNvPr>
           <p:cNvPicPr>
             <a:picLocks noChangeAspect="1"/>
           </p:cNvPicPr>
@@ -4872,8 +5046,8 @@
         </p:blipFill>
         <p:spPr>
           <a:xfrm>
-            <a:off x="1060704" y="2386584"/>
-            <a:ext cx="438912" cy="438912"/>
+            <a:off x="1301191" y="2307031"/>
+            <a:ext cx="460858" cy="460858"/>
           </a:xfrm>
           <a:prstGeom prst="rect">
             <a:avLst/>
@@ -4882,14 +5056,36 @@
       </p:pic>
       <p:sp>
         <p:nvSpPr>
-          <p:cNvPr id="6" name="Text 3"/>
-          <p:cNvSpPr/>
-          <p:nvPr/>
-        </p:nvSpPr>
-        <p:spPr>
-          <a:xfrm>
-            <a:off x="2011680" y="2167128"/>
-            <a:ext cx="3931920" cy="502920"/>
+          <p:cNvPr id="10" name="Shape 7"/>
+          <p:cNvSpPr/>
+          <p:nvPr/>
+        </p:nvSpPr>
+        <p:spPr>
+          <a:xfrm>
+            <a:off x="3611880" y="2194560"/>
+            <a:ext cx="2011680" cy="457200"/>
+          </a:xfrm>
+          <a:prstGeom prst="roundRect">
+            <a:avLst>
+              <a:gd name="adj" fmla="val 50000"/>
+            </a:avLst>
+          </a:prstGeom>
+          <a:solidFill>
+            <a:srgbClr val="45B84B"/>
+          </a:solidFill>
+          <a:ln/>
+        </p:spPr>
+      </p:sp>
+      <p:sp>
+        <p:nvSpPr>
+          <p:cNvPr id="11" name="Text 8"/>
+          <p:cNvSpPr/>
+          <p:nvPr/>
+        </p:nvSpPr>
+        <p:spPr>
+          <a:xfrm>
+            <a:off x="3611880" y="2194560"/>
+            <a:ext cx="2011680" cy="457200"/>
           </a:xfrm>
           <a:prstGeom prst="rect">
             <a:avLst/>
@@ -4901,11 +5097,50 @@
           <a:bodyPr wrap="square" lIns="0" tIns="0" rIns="0" bIns="0" rtlCol="0" anchor="ctr"/>
           <a:lstStyle/>
           <a:p>
+            <a:pPr algn="ctr" indent="0" marL="0">
+              <a:buNone/>
+            </a:pPr>
+            <a:r>
+              <a:rPr lang="en-US" sz="1100" b="1" dirty="0">
+                <a:solidFill>
+                  <a:srgbClr val="FFFFFF"/>
+                </a:solidFill>
+                <a:latin typeface="Calibri" pitchFamily="34" charset="0"/>
+                <a:ea typeface="Calibri" pitchFamily="34" charset="-122"/>
+                <a:cs typeface="Calibri" pitchFamily="34" charset="-120"/>
+              </a:rPr>
+              <a:t>Au Bénin</a:t>
+            </a:r>
+            <a:endParaRPr lang="en-US" sz="1100" dirty="0"/>
+          </a:p>
+        </p:txBody>
+      </p:sp>
+      <p:sp>
+        <p:nvSpPr>
+          <p:cNvPr id="12" name="Text 9"/>
+          <p:cNvSpPr/>
+          <p:nvPr/>
+        </p:nvSpPr>
+        <p:spPr>
+          <a:xfrm>
+            <a:off x="1051560" y="3291840"/>
+            <a:ext cx="4526280" cy="822960"/>
+          </a:xfrm>
+          <a:prstGeom prst="rect">
+            <a:avLst/>
+          </a:prstGeom>
+          <a:noFill/>
+          <a:ln/>
+        </p:spPr>
+        <p:txBody>
+          <a:bodyPr wrap="square" lIns="0" tIns="0" rIns="0" bIns="0" rtlCol="0" anchor="ctr"/>
+          <a:lstStyle/>
+          <a:p>
             <a:pPr indent="0" marL="0">
               <a:buNone/>
             </a:pPr>
             <a:r>
-              <a:rPr lang="en-US" sz="2000" b="1" dirty="0">
+              <a:rPr lang="en-US" sz="2100" b="1" dirty="0">
                 <a:solidFill>
                   <a:srgbClr val="2F3C7E"/>
                 </a:solidFill>
@@ -4913,22 +5148,22 @@
                 <a:ea typeface="Cambria" pitchFamily="34" charset="-122"/>
                 <a:cs typeface="Cambria" pitchFamily="34" charset="-120"/>
               </a:rPr>
-              <a:t>Éducation</a:t>
-            </a:r>
-            <a:endParaRPr lang="en-US" sz="2000" dirty="0"/>
-          </a:p>
-        </p:txBody>
-      </p:sp>
-      <p:sp>
-        <p:nvSpPr>
-          <p:cNvPr id="7" name="Text 4"/>
-          <p:cNvSpPr/>
-          <p:nvPr/>
-        </p:nvSpPr>
-        <p:spPr>
-          <a:xfrm>
-            <a:off x="2011680" y="2651760"/>
-            <a:ext cx="5943600" cy="457200"/>
+              <a:t>Les familles en grande difficulté</a:t>
+            </a:r>
+            <a:endParaRPr lang="en-US" sz="2100" dirty="0"/>
+          </a:p>
+        </p:txBody>
+      </p:sp>
+      <p:sp>
+        <p:nvSpPr>
+          <p:cNvPr id="13" name="Text 10"/>
+          <p:cNvSpPr/>
+          <p:nvPr/>
+        </p:nvSpPr>
+        <p:spPr>
+          <a:xfrm>
+            <a:off x="1051560" y="4160520"/>
+            <a:ext cx="4526280" cy="1371600"/>
           </a:xfrm>
           <a:prstGeom prst="rect">
             <a:avLst/>
@@ -4937,7 +5172,7 @@
           <a:ln/>
         </p:spPr>
         <p:txBody>
-          <a:bodyPr wrap="square" lIns="0" tIns="0" rIns="0" bIns="0" rtlCol="0" anchor="ctr"/>
+          <a:bodyPr wrap="square" lIns="0" tIns="0" rIns="0" bIns="0" rtlCol="0" anchor="t"/>
           <a:lstStyle/>
           <a:p>
             <a:pPr indent="0" marL="0">
@@ -4952,7 +5187,7 @@
                 <a:ea typeface="Calibri" pitchFamily="34" charset="-122"/>
                 <a:cs typeface="Calibri" pitchFamily="34" charset="-120"/>
               </a:rPr>
-              <a:t>Permettre à chaque enfant d’aller à l’école et d’y rester.</a:t>
+              <a:t>Nous apportons une aide adaptée à leurs besoins essentiels : alimentation, vêtements, soutien matériel.</a:t>
             </a:r>
             <a:endParaRPr lang="en-US" sz="1400" dirty="0"/>
           </a:p>
@@ -4960,27 +5195,56 @@
       </p:sp>
       <p:sp>
         <p:nvSpPr>
-          <p:cNvPr id="8" name="Shape 5"/>
-          <p:cNvSpPr/>
-          <p:nvPr/>
-        </p:nvSpPr>
-        <p:spPr>
-          <a:xfrm>
-            <a:off x="822960" y="3429000"/>
-            <a:ext cx="914400" cy="914400"/>
+          <p:cNvPr id="14" name="Shape 11"/>
+          <p:cNvSpPr/>
+          <p:nvPr/>
+        </p:nvSpPr>
+        <p:spPr>
+          <a:xfrm>
+            <a:off x="6199632" y="1645920"/>
+            <a:ext cx="5349240" cy="4023360"/>
+          </a:xfrm>
+          <a:prstGeom prst="roundRect">
+            <a:avLst>
+              <a:gd name="adj" fmla="val 2727"/>
+            </a:avLst>
+          </a:prstGeom>
+          <a:solidFill>
+            <a:srgbClr val="F4F5FA"/>
+          </a:solidFill>
+          <a:ln/>
+          <a:effectLst>
+            <a:outerShdw sx="100000" sy="100000" kx="0" ky="0" algn="bl" rotWithShape="0" blurRad="76200" dist="25400" dir="5400000">
+              <a:srgbClr val="AAAAAA">
+                <a:alpha val="30000"/>
+              </a:srgbClr>
+            </a:outerShdw>
+          </a:effectLst>
+        </p:spPr>
+      </p:sp>
+      <p:sp>
+        <p:nvSpPr>
+          <p:cNvPr id="15" name="Shape 12"/>
+          <p:cNvSpPr/>
+          <p:nvPr/>
+        </p:nvSpPr>
+        <p:spPr>
+          <a:xfrm>
+            <a:off x="6611112" y="2057400"/>
+            <a:ext cx="960120" cy="960120"/>
           </a:xfrm>
           <a:prstGeom prst="ellipse">
             <a:avLst/>
           </a:prstGeom>
           <a:solidFill>
-            <a:srgbClr val="2F3C7E"/>
+            <a:srgbClr val="2BA8E0"/>
           </a:solidFill>
           <a:ln/>
         </p:spPr>
       </p:sp>
       <p:pic>
         <p:nvPicPr>
-          <p:cNvPr id="9" name="Image 1" descr="preencoded.png">    </p:cNvPr>
+          <p:cNvPr id="16" name="Image 1" descr="preencoded.png">    </p:cNvPr>
           <p:cNvPicPr>
             <a:picLocks noChangeAspect="1"/>
           </p:cNvPicPr>
@@ -4994,8 +5258,8 @@
         </p:blipFill>
         <p:spPr>
           <a:xfrm>
-            <a:off x="1060704" y="3666744"/>
-            <a:ext cx="438912" cy="438912"/>
+            <a:off x="6860743" y="2307031"/>
+            <a:ext cx="460858" cy="460858"/>
           </a:xfrm>
           <a:prstGeom prst="rect">
             <a:avLst/>
@@ -5004,14 +5268,36 @@
       </p:pic>
       <p:sp>
         <p:nvSpPr>
-          <p:cNvPr id="10" name="Text 6"/>
-          <p:cNvSpPr/>
-          <p:nvPr/>
-        </p:nvSpPr>
-        <p:spPr>
-          <a:xfrm>
-            <a:off x="2011680" y="3447288"/>
-            <a:ext cx="3931920" cy="502920"/>
+          <p:cNvPr id="17" name="Shape 13"/>
+          <p:cNvSpPr/>
+          <p:nvPr/>
+        </p:nvSpPr>
+        <p:spPr>
+          <a:xfrm>
+            <a:off x="9171432" y="2194560"/>
+            <a:ext cx="2011680" cy="457200"/>
+          </a:xfrm>
+          <a:prstGeom prst="roundRect">
+            <a:avLst>
+              <a:gd name="adj" fmla="val 50000"/>
+            </a:avLst>
+          </a:prstGeom>
+          <a:solidFill>
+            <a:srgbClr val="2BA8E0"/>
+          </a:solidFill>
+          <a:ln/>
+        </p:spPr>
+      </p:sp>
+      <p:sp>
+        <p:nvSpPr>
+          <p:cNvPr id="18" name="Text 14"/>
+          <p:cNvSpPr/>
+          <p:nvPr/>
+        </p:nvSpPr>
+        <p:spPr>
+          <a:xfrm>
+            <a:off x="9171432" y="2194560"/>
+            <a:ext cx="2011680" cy="457200"/>
           </a:xfrm>
           <a:prstGeom prst="rect">
             <a:avLst/>
@@ -5023,11 +5309,50 @@
           <a:bodyPr wrap="square" lIns="0" tIns="0" rIns="0" bIns="0" rtlCol="0" anchor="ctr"/>
           <a:lstStyle/>
           <a:p>
+            <a:pPr algn="ctr" indent="0" marL="0">
+              <a:buNone/>
+            </a:pPr>
+            <a:r>
+              <a:rPr lang="en-US" sz="1100" b="1" dirty="0">
+                <a:solidFill>
+                  <a:srgbClr val="FFFFFF"/>
+                </a:solidFill>
+                <a:latin typeface="Calibri" pitchFamily="34" charset="0"/>
+                <a:ea typeface="Calibri" pitchFamily="34" charset="-122"/>
+                <a:cs typeface="Calibri" pitchFamily="34" charset="-120"/>
+              </a:rPr>
+              <a:t>En France — depuis 2024</a:t>
+            </a:r>
+            <a:endParaRPr lang="en-US" sz="1100" dirty="0"/>
+          </a:p>
+        </p:txBody>
+      </p:sp>
+      <p:sp>
+        <p:nvSpPr>
+          <p:cNvPr id="19" name="Text 15"/>
+          <p:cNvSpPr/>
+          <p:nvPr/>
+        </p:nvSpPr>
+        <p:spPr>
+          <a:xfrm>
+            <a:off x="6611112" y="3291840"/>
+            <a:ext cx="4526280" cy="822960"/>
+          </a:xfrm>
+          <a:prstGeom prst="rect">
+            <a:avLst/>
+          </a:prstGeom>
+          <a:noFill/>
+          <a:ln/>
+        </p:spPr>
+        <p:txBody>
+          <a:bodyPr wrap="square" lIns="0" tIns="0" rIns="0" bIns="0" rtlCol="0" anchor="ctr"/>
+          <a:lstStyle/>
+          <a:p>
             <a:pPr indent="0" marL="0">
               <a:buNone/>
             </a:pPr>
             <a:r>
-              <a:rPr lang="en-US" sz="2000" b="1" dirty="0">
+              <a:rPr lang="en-US" sz="2100" b="1" dirty="0">
                 <a:solidFill>
                   <a:srgbClr val="2F3C7E"/>
                 </a:solidFill>
@@ -5035,22 +5360,22 @@
                 <a:ea typeface="Cambria" pitchFamily="34" charset="-122"/>
                 <a:cs typeface="Cambria" pitchFamily="34" charset="-120"/>
               </a:rPr>
-              <a:t>Santé</a:t>
-            </a:r>
-            <a:endParaRPr lang="en-US" sz="2000" dirty="0"/>
-          </a:p>
-        </p:txBody>
-      </p:sp>
-      <p:sp>
-        <p:nvSpPr>
-          <p:cNvPr id="11" name="Text 7"/>
-          <p:cNvSpPr/>
-          <p:nvPr/>
-        </p:nvSpPr>
-        <p:spPr>
-          <a:xfrm>
-            <a:off x="2011680" y="3931920"/>
-            <a:ext cx="5943600" cy="457200"/>
+              <a:t>Les personnes sans abri</a:t>
+            </a:r>
+            <a:endParaRPr lang="en-US" sz="2100" dirty="0"/>
+          </a:p>
+        </p:txBody>
+      </p:sp>
+      <p:sp>
+        <p:nvSpPr>
+          <p:cNvPr id="20" name="Text 16"/>
+          <p:cNvSpPr/>
+          <p:nvPr/>
+        </p:nvSpPr>
+        <p:spPr>
+          <a:xfrm>
+            <a:off x="6611112" y="4160520"/>
+            <a:ext cx="4526280" cy="1371600"/>
           </a:xfrm>
           <a:prstGeom prst="rect">
             <a:avLst/>
@@ -5059,7 +5384,7 @@
           <a:ln/>
         </p:spPr>
         <p:txBody>
-          <a:bodyPr wrap="square" lIns="0" tIns="0" rIns="0" bIns="0" rtlCol="0" anchor="ctr"/>
+          <a:bodyPr wrap="square" lIns="0" tIns="0" rIns="0" bIns="0" rtlCol="0" anchor="t"/>
           <a:lstStyle/>
           <a:p>
             <a:pPr indent="0" marL="0">
@@ -5074,231 +5399,9 @@
                 <a:ea typeface="Calibri" pitchFamily="34" charset="-122"/>
                 <a:cs typeface="Calibri" pitchFamily="34" charset="-120"/>
               </a:rPr>
-              <a:t>Améliorer l’accès aux soins des enfants et de leurs familles.</a:t>
+              <a:t>Depuis 2024, nous menons en France des distributions et des actions solidaires destinées à améliorer leur quotidien.</a:t>
             </a:r>
             <a:endParaRPr lang="en-US" sz="1400" dirty="0"/>
-          </a:p>
-        </p:txBody>
-      </p:sp>
-      <p:sp>
-        <p:nvSpPr>
-          <p:cNvPr id="12" name="Shape 8"/>
-          <p:cNvSpPr/>
-          <p:nvPr/>
-        </p:nvSpPr>
-        <p:spPr>
-          <a:xfrm>
-            <a:off x="822960" y="4709160"/>
-            <a:ext cx="914400" cy="914400"/>
-          </a:xfrm>
-          <a:prstGeom prst="ellipse">
-            <a:avLst/>
-          </a:prstGeom>
-          <a:solidFill>
-            <a:srgbClr val="2F3C7E"/>
-          </a:solidFill>
-          <a:ln/>
-        </p:spPr>
-      </p:sp>
-      <p:pic>
-        <p:nvPicPr>
-          <p:cNvPr id="13" name="Image 2" descr="preencoded.png">    </p:cNvPr>
-          <p:cNvPicPr>
-            <a:picLocks noChangeAspect="1"/>
-          </p:cNvPicPr>
-          <p:nvPr/>
-        </p:nvPicPr>
-        <p:blipFill>
-          <a:blip r:embed="rId3"/>
-          <a:stretch>
-            <a:fillRect/>
-          </a:stretch>
-        </p:blipFill>
-        <p:spPr>
-          <a:xfrm>
-            <a:off x="1060704" y="4946904"/>
-            <a:ext cx="438912" cy="438912"/>
-          </a:xfrm>
-          <a:prstGeom prst="rect">
-            <a:avLst/>
-          </a:prstGeom>
-        </p:spPr>
-      </p:pic>
-      <p:sp>
-        <p:nvSpPr>
-          <p:cNvPr id="14" name="Text 9"/>
-          <p:cNvSpPr/>
-          <p:nvPr/>
-        </p:nvSpPr>
-        <p:spPr>
-          <a:xfrm>
-            <a:off x="2011680" y="4727448"/>
-            <a:ext cx="3931920" cy="502920"/>
-          </a:xfrm>
-          <a:prstGeom prst="rect">
-            <a:avLst/>
-          </a:prstGeom>
-          <a:noFill/>
-          <a:ln/>
-        </p:spPr>
-        <p:txBody>
-          <a:bodyPr wrap="square" lIns="0" tIns="0" rIns="0" bIns="0" rtlCol="0" anchor="ctr"/>
-          <a:lstStyle/>
-          <a:p>
-            <a:pPr indent="0" marL="0">
-              <a:buNone/>
-            </a:pPr>
-            <a:r>
-              <a:rPr lang="en-US" sz="2000" b="1" dirty="0">
-                <a:solidFill>
-                  <a:srgbClr val="2F3C7E"/>
-                </a:solidFill>
-                <a:latin typeface="Cambria" pitchFamily="34" charset="0"/>
-                <a:ea typeface="Cambria" pitchFamily="34" charset="-122"/>
-                <a:cs typeface="Cambria" pitchFamily="34" charset="-120"/>
-              </a:rPr>
-              <a:t>Autonomie des familles</a:t>
-            </a:r>
-            <a:endParaRPr lang="en-US" sz="2000" dirty="0"/>
-          </a:p>
-        </p:txBody>
-      </p:sp>
-      <p:sp>
-        <p:nvSpPr>
-          <p:cNvPr id="15" name="Text 10"/>
-          <p:cNvSpPr/>
-          <p:nvPr/>
-        </p:nvSpPr>
-        <p:spPr>
-          <a:xfrm>
-            <a:off x="2011680" y="5212080"/>
-            <a:ext cx="5943600" cy="457200"/>
-          </a:xfrm>
-          <a:prstGeom prst="rect">
-            <a:avLst/>
-          </a:prstGeom>
-          <a:noFill/>
-          <a:ln/>
-        </p:spPr>
-        <p:txBody>
-          <a:bodyPr wrap="square" lIns="0" tIns="0" rIns="0" bIns="0" rtlCol="0" anchor="ctr"/>
-          <a:lstStyle/>
-          <a:p>
-            <a:pPr indent="0" marL="0">
-              <a:buNone/>
-            </a:pPr>
-            <a:r>
-              <a:rPr lang="en-US" sz="1400" dirty="0">
-                <a:solidFill>
-                  <a:srgbClr val="444444"/>
-                </a:solidFill>
-                <a:latin typeface="Calibri" pitchFamily="34" charset="0"/>
-                <a:ea typeface="Calibri" pitchFamily="34" charset="-122"/>
-                <a:cs typeface="Calibri" pitchFamily="34" charset="-120"/>
-              </a:rPr>
-              <a:t>Aider les familles à construire des ressources durables.</a:t>
-            </a:r>
-            <a:endParaRPr lang="en-US" sz="1400" dirty="0"/>
-          </a:p>
-        </p:txBody>
-      </p:sp>
-      <p:sp>
-        <p:nvSpPr>
-          <p:cNvPr id="16" name="Shape 11"/>
-          <p:cNvSpPr/>
-          <p:nvPr/>
-        </p:nvSpPr>
-        <p:spPr>
-          <a:xfrm>
-            <a:off x="8412480" y="2148840"/>
-            <a:ext cx="3108960" cy="3566160"/>
-          </a:xfrm>
-          <a:prstGeom prst="roundRect">
-            <a:avLst>
-              <a:gd name="adj" fmla="val 3529"/>
-            </a:avLst>
-          </a:prstGeom>
-          <a:solidFill>
-            <a:srgbClr val="2F3C7E"/>
-          </a:solidFill>
-          <a:ln/>
-        </p:spPr>
-      </p:sp>
-      <p:sp>
-        <p:nvSpPr>
-          <p:cNvPr id="17" name="Text 12"/>
-          <p:cNvSpPr/>
-          <p:nvPr/>
-        </p:nvSpPr>
-        <p:spPr>
-          <a:xfrm>
-            <a:off x="8686800" y="2468880"/>
-            <a:ext cx="2560320" cy="1188720"/>
-          </a:xfrm>
-          <a:prstGeom prst="rect">
-            <a:avLst/>
-          </a:prstGeom>
-          <a:noFill/>
-          <a:ln/>
-        </p:spPr>
-        <p:txBody>
-          <a:bodyPr wrap="square" rtlCol="0" anchor="ctr"/>
-          <a:lstStyle/>
-          <a:p>
-            <a:pPr algn="ctr" indent="0" marL="0">
-              <a:buNone/>
-            </a:pPr>
-            <a:r>
-              <a:rPr lang="en-US" sz="1700" i="1" dirty="0">
-                <a:solidFill>
-                  <a:srgbClr val="F9E795"/>
-                </a:solidFill>
-                <a:latin typeface="Cambria" pitchFamily="34" charset="0"/>
-                <a:ea typeface="Cambria" pitchFamily="34" charset="-122"/>
-                <a:cs typeface="Cambria" pitchFamily="34" charset="-120"/>
-              </a:rPr>
-              <a:t>« Parce que chaque geste compte »</a:t>
-            </a:r>
-            <a:endParaRPr lang="en-US" sz="1700" dirty="0"/>
-          </a:p>
-        </p:txBody>
-      </p:sp>
-      <p:sp>
-        <p:nvSpPr>
-          <p:cNvPr id="18" name="Text 13"/>
-          <p:cNvSpPr/>
-          <p:nvPr/>
-        </p:nvSpPr>
-        <p:spPr>
-          <a:xfrm>
-            <a:off x="8686800" y="3749040"/>
-            <a:ext cx="2560320" cy="1737360"/>
-          </a:xfrm>
-          <a:prstGeom prst="rect">
-            <a:avLst/>
-          </a:prstGeom>
-          <a:noFill/>
-          <a:ln/>
-        </p:spPr>
-        <p:txBody>
-          <a:bodyPr wrap="square" rtlCol="0" anchor="ctr"/>
-          <a:lstStyle/>
-          <a:p>
-            <a:pPr algn="ctr" indent="0" marL="0">
-              <a:buNone/>
-            </a:pPr>
-            <a:r>
-              <a:rPr lang="en-US" sz="1300" dirty="0">
-                <a:solidFill>
-                  <a:srgbClr val="DDE1F2"/>
-                </a:solidFill>
-                <a:latin typeface="Calibri" pitchFamily="34" charset="0"/>
-                <a:ea typeface="Calibri" pitchFamily="34" charset="-122"/>
-                <a:cs typeface="Calibri" pitchFamily="34" charset="-120"/>
-              </a:rPr>
-              <a:t>D’une aide ponctuelle vers un véritable changement durable dans la vie des bénéficiaires.</a:t>
-            </a:r>
-            <a:endParaRPr lang="en-US" sz="1300" dirty="0"/>
           </a:p>
         </p:txBody>
       </p:sp>
@@ -5313,6 +5416,582 @@
 <file path=ppt/slides/slide8.xml><?xml version="1.0" encoding="utf-8"?>
 <p:sld xmlns:a="http://schemas.openxmlformats.org/drawingml/2006/main" xmlns:r="http://schemas.openxmlformats.org/officeDocument/2006/relationships" xmlns:p="http://schemas.openxmlformats.org/presentationml/2006/main">
   <p:cSld name="Slide 8">
+    <p:bg>
+      <p:bgPr>
+        <a:solidFill>
+          <a:srgbClr val="FFFFFF"/>
+        </a:solidFill>
+      </p:bgPr>
+    </p:bg>
+    <p:spTree>
+      <p:nvGrpSpPr>
+        <p:cNvPr id="1" name=""/>
+        <p:cNvGrpSpPr/>
+        <p:nvPr/>
+      </p:nvGrpSpPr>
+      <p:grpSpPr>
+        <a:xfrm>
+          <a:off x="0" y="0"/>
+          <a:ext cx="0" cy="0"/>
+          <a:chOff x="0" y="0"/>
+          <a:chExt cx="0" cy="0"/>
+        </a:xfrm>
+      </p:grpSpPr>
+      <p:sp>
+        <p:nvSpPr>
+          <p:cNvPr id="2" name="Text 0"/>
+          <p:cNvSpPr/>
+          <p:nvPr/>
+        </p:nvSpPr>
+        <p:spPr>
+          <a:xfrm>
+            <a:off x="640080" y="411480"/>
+            <a:ext cx="10058400" cy="731520"/>
+          </a:xfrm>
+          <a:prstGeom prst="rect">
+            <a:avLst/>
+          </a:prstGeom>
+          <a:noFill/>
+          <a:ln/>
+        </p:spPr>
+        <p:txBody>
+          <a:bodyPr wrap="square" rtlCol="0" anchor="ctr"/>
+          <a:lstStyle/>
+          <a:p>
+            <a:pPr indent="0" marL="0">
+              <a:buNone/>
+            </a:pPr>
+            <a:r>
+              <a:rPr lang="en-US" sz="3800" b="1" dirty="0">
+                <a:solidFill>
+                  <a:srgbClr val="2F3C7E"/>
+                </a:solidFill>
+                <a:latin typeface="Cambria" pitchFamily="34" charset="0"/>
+                <a:ea typeface="Cambria" pitchFamily="34" charset="-122"/>
+                <a:cs typeface="Cambria" pitchFamily="34" charset="-120"/>
+              </a:rPr>
+              <a:t>Notre ambition</a:t>
+            </a:r>
+            <a:endParaRPr lang="en-US" sz="3800" dirty="0"/>
+          </a:p>
+        </p:txBody>
+      </p:sp>
+      <p:sp>
+        <p:nvSpPr>
+          <p:cNvPr id="3" name="Text 1"/>
+          <p:cNvSpPr/>
+          <p:nvPr/>
+        </p:nvSpPr>
+        <p:spPr>
+          <a:xfrm>
+            <a:off x="640080" y="1188720"/>
+            <a:ext cx="10881360" cy="777240"/>
+          </a:xfrm>
+          <a:prstGeom prst="rect">
+            <a:avLst/>
+          </a:prstGeom>
+          <a:noFill/>
+          <a:ln/>
+        </p:spPr>
+        <p:txBody>
+          <a:bodyPr wrap="square" rtlCol="0" anchor="ctr"/>
+          <a:lstStyle/>
+          <a:p>
+            <a:pPr indent="0" marL="0">
+              <a:buNone/>
+            </a:pPr>
+            <a:r>
+              <a:rPr lang="en-US" sz="1500" i="1" dirty="0">
+                <a:solidFill>
+                  <a:srgbClr val="5A5A6E"/>
+                </a:solidFill>
+                <a:latin typeface="Calibri" pitchFamily="34" charset="0"/>
+                <a:ea typeface="Calibri" pitchFamily="34" charset="-122"/>
+                <a:cs typeface="Calibri" pitchFamily="34" charset="-120"/>
+              </a:rPr>
+              <a:t>Continuer à grandir pour aider plus d’enfants, soutenir plus de familles, et poursuivre nos actions auprès des personnes sans abri — avec des projets durables qui changent réellement les vies.</a:t>
+            </a:r>
+            <a:endParaRPr lang="en-US" sz="1500" dirty="0"/>
+          </a:p>
+        </p:txBody>
+      </p:sp>
+      <p:sp>
+        <p:nvSpPr>
+          <p:cNvPr id="4" name="Shape 2"/>
+          <p:cNvSpPr/>
+          <p:nvPr/>
+        </p:nvSpPr>
+        <p:spPr>
+          <a:xfrm>
+            <a:off x="822960" y="2148840"/>
+            <a:ext cx="914400" cy="914400"/>
+          </a:xfrm>
+          <a:prstGeom prst="ellipse">
+            <a:avLst/>
+          </a:prstGeom>
+          <a:solidFill>
+            <a:srgbClr val="2BA8E0"/>
+          </a:solidFill>
+          <a:ln/>
+        </p:spPr>
+      </p:sp>
+      <p:pic>
+        <p:nvPicPr>
+          <p:cNvPr id="5" name="Image 0" descr="preencoded.png">    </p:cNvPr>
+          <p:cNvPicPr>
+            <a:picLocks noChangeAspect="1"/>
+          </p:cNvPicPr>
+          <p:nvPr/>
+        </p:nvPicPr>
+        <p:blipFill>
+          <a:blip r:embed="rId1"/>
+          <a:stretch>
+            <a:fillRect/>
+          </a:stretch>
+        </p:blipFill>
+        <p:spPr>
+          <a:xfrm>
+            <a:off x="1060704" y="2386584"/>
+            <a:ext cx="438912" cy="438912"/>
+          </a:xfrm>
+          <a:prstGeom prst="rect">
+            <a:avLst/>
+          </a:prstGeom>
+        </p:spPr>
+      </p:pic>
+      <p:sp>
+        <p:nvSpPr>
+          <p:cNvPr id="6" name="Text 3"/>
+          <p:cNvSpPr/>
+          <p:nvPr/>
+        </p:nvSpPr>
+        <p:spPr>
+          <a:xfrm>
+            <a:off x="2011680" y="2167128"/>
+            <a:ext cx="3931920" cy="502920"/>
+          </a:xfrm>
+          <a:prstGeom prst="rect">
+            <a:avLst/>
+          </a:prstGeom>
+          <a:noFill/>
+          <a:ln/>
+        </p:spPr>
+        <p:txBody>
+          <a:bodyPr wrap="square" lIns="0" tIns="0" rIns="0" bIns="0" rtlCol="0" anchor="ctr"/>
+          <a:lstStyle/>
+          <a:p>
+            <a:pPr indent="0" marL="0">
+              <a:buNone/>
+            </a:pPr>
+            <a:r>
+              <a:rPr lang="en-US" sz="2000" b="1" dirty="0">
+                <a:solidFill>
+                  <a:srgbClr val="2F3C7E"/>
+                </a:solidFill>
+                <a:latin typeface="Cambria" pitchFamily="34" charset="0"/>
+                <a:ea typeface="Cambria" pitchFamily="34" charset="-122"/>
+                <a:cs typeface="Cambria" pitchFamily="34" charset="-120"/>
+              </a:rPr>
+              <a:t>Éducation</a:t>
+            </a:r>
+            <a:endParaRPr lang="en-US" sz="2000" dirty="0"/>
+          </a:p>
+        </p:txBody>
+      </p:sp>
+      <p:sp>
+        <p:nvSpPr>
+          <p:cNvPr id="7" name="Text 4"/>
+          <p:cNvSpPr/>
+          <p:nvPr/>
+        </p:nvSpPr>
+        <p:spPr>
+          <a:xfrm>
+            <a:off x="2011680" y="2651760"/>
+            <a:ext cx="5943600" cy="457200"/>
+          </a:xfrm>
+          <a:prstGeom prst="rect">
+            <a:avLst/>
+          </a:prstGeom>
+          <a:noFill/>
+          <a:ln/>
+        </p:spPr>
+        <p:txBody>
+          <a:bodyPr wrap="square" lIns="0" tIns="0" rIns="0" bIns="0" rtlCol="0" anchor="ctr"/>
+          <a:lstStyle/>
+          <a:p>
+            <a:pPr indent="0" marL="0">
+              <a:buNone/>
+            </a:pPr>
+            <a:r>
+              <a:rPr lang="en-US" sz="1400" dirty="0">
+                <a:solidFill>
+                  <a:srgbClr val="444444"/>
+                </a:solidFill>
+                <a:latin typeface="Calibri" pitchFamily="34" charset="0"/>
+                <a:ea typeface="Calibri" pitchFamily="34" charset="-122"/>
+                <a:cs typeface="Calibri" pitchFamily="34" charset="-120"/>
+              </a:rPr>
+              <a:t>Permettre à chaque enfant d’aller à l’école et d’y rester.</a:t>
+            </a:r>
+            <a:endParaRPr lang="en-US" sz="1400" dirty="0"/>
+          </a:p>
+        </p:txBody>
+      </p:sp>
+      <p:sp>
+        <p:nvSpPr>
+          <p:cNvPr id="8" name="Shape 5"/>
+          <p:cNvSpPr/>
+          <p:nvPr/>
+        </p:nvSpPr>
+        <p:spPr>
+          <a:xfrm>
+            <a:off x="822960" y="3429000"/>
+            <a:ext cx="914400" cy="914400"/>
+          </a:xfrm>
+          <a:prstGeom prst="ellipse">
+            <a:avLst/>
+          </a:prstGeom>
+          <a:solidFill>
+            <a:srgbClr val="F9931D"/>
+          </a:solidFill>
+          <a:ln/>
+        </p:spPr>
+      </p:sp>
+      <p:pic>
+        <p:nvPicPr>
+          <p:cNvPr id="9" name="Image 1" descr="preencoded.png">    </p:cNvPr>
+          <p:cNvPicPr>
+            <a:picLocks noChangeAspect="1"/>
+          </p:cNvPicPr>
+          <p:nvPr/>
+        </p:nvPicPr>
+        <p:blipFill>
+          <a:blip r:embed="rId2"/>
+          <a:stretch>
+            <a:fillRect/>
+          </a:stretch>
+        </p:blipFill>
+        <p:spPr>
+          <a:xfrm>
+            <a:off x="1060704" y="3666744"/>
+            <a:ext cx="438912" cy="438912"/>
+          </a:xfrm>
+          <a:prstGeom prst="rect">
+            <a:avLst/>
+          </a:prstGeom>
+        </p:spPr>
+      </p:pic>
+      <p:sp>
+        <p:nvSpPr>
+          <p:cNvPr id="10" name="Text 6"/>
+          <p:cNvSpPr/>
+          <p:nvPr/>
+        </p:nvSpPr>
+        <p:spPr>
+          <a:xfrm>
+            <a:off x="2011680" y="3447288"/>
+            <a:ext cx="3931920" cy="502920"/>
+          </a:xfrm>
+          <a:prstGeom prst="rect">
+            <a:avLst/>
+          </a:prstGeom>
+          <a:noFill/>
+          <a:ln/>
+        </p:spPr>
+        <p:txBody>
+          <a:bodyPr wrap="square" lIns="0" tIns="0" rIns="0" bIns="0" rtlCol="0" anchor="ctr"/>
+          <a:lstStyle/>
+          <a:p>
+            <a:pPr indent="0" marL="0">
+              <a:buNone/>
+            </a:pPr>
+            <a:r>
+              <a:rPr lang="en-US" sz="2000" b="1" dirty="0">
+                <a:solidFill>
+                  <a:srgbClr val="2F3C7E"/>
+                </a:solidFill>
+                <a:latin typeface="Cambria" pitchFamily="34" charset="0"/>
+                <a:ea typeface="Cambria" pitchFamily="34" charset="-122"/>
+                <a:cs typeface="Cambria" pitchFamily="34" charset="-120"/>
+              </a:rPr>
+              <a:t>Santé</a:t>
+            </a:r>
+            <a:endParaRPr lang="en-US" sz="2000" dirty="0"/>
+          </a:p>
+        </p:txBody>
+      </p:sp>
+      <p:sp>
+        <p:nvSpPr>
+          <p:cNvPr id="11" name="Text 7"/>
+          <p:cNvSpPr/>
+          <p:nvPr/>
+        </p:nvSpPr>
+        <p:spPr>
+          <a:xfrm>
+            <a:off x="2011680" y="3931920"/>
+            <a:ext cx="5943600" cy="457200"/>
+          </a:xfrm>
+          <a:prstGeom prst="rect">
+            <a:avLst/>
+          </a:prstGeom>
+          <a:noFill/>
+          <a:ln/>
+        </p:spPr>
+        <p:txBody>
+          <a:bodyPr wrap="square" lIns="0" tIns="0" rIns="0" bIns="0" rtlCol="0" anchor="ctr"/>
+          <a:lstStyle/>
+          <a:p>
+            <a:pPr indent="0" marL="0">
+              <a:buNone/>
+            </a:pPr>
+            <a:r>
+              <a:rPr lang="en-US" sz="1400" dirty="0">
+                <a:solidFill>
+                  <a:srgbClr val="444444"/>
+                </a:solidFill>
+                <a:latin typeface="Calibri" pitchFamily="34" charset="0"/>
+                <a:ea typeface="Calibri" pitchFamily="34" charset="-122"/>
+                <a:cs typeface="Calibri" pitchFamily="34" charset="-120"/>
+              </a:rPr>
+              <a:t>Améliorer l’accès aux soins des enfants et de leurs familles.</a:t>
+            </a:r>
+            <a:endParaRPr lang="en-US" sz="1400" dirty="0"/>
+          </a:p>
+        </p:txBody>
+      </p:sp>
+      <p:sp>
+        <p:nvSpPr>
+          <p:cNvPr id="12" name="Shape 8"/>
+          <p:cNvSpPr/>
+          <p:nvPr/>
+        </p:nvSpPr>
+        <p:spPr>
+          <a:xfrm>
+            <a:off x="822960" y="4709160"/>
+            <a:ext cx="914400" cy="914400"/>
+          </a:xfrm>
+          <a:prstGeom prst="ellipse">
+            <a:avLst/>
+          </a:prstGeom>
+          <a:solidFill>
+            <a:srgbClr val="45B84B"/>
+          </a:solidFill>
+          <a:ln/>
+        </p:spPr>
+      </p:sp>
+      <p:pic>
+        <p:nvPicPr>
+          <p:cNvPr id="13" name="Image 2" descr="preencoded.png">    </p:cNvPr>
+          <p:cNvPicPr>
+            <a:picLocks noChangeAspect="1"/>
+          </p:cNvPicPr>
+          <p:nvPr/>
+        </p:nvPicPr>
+        <p:blipFill>
+          <a:blip r:embed="rId3"/>
+          <a:stretch>
+            <a:fillRect/>
+          </a:stretch>
+        </p:blipFill>
+        <p:spPr>
+          <a:xfrm>
+            <a:off x="1060704" y="4946904"/>
+            <a:ext cx="438912" cy="438912"/>
+          </a:xfrm>
+          <a:prstGeom prst="rect">
+            <a:avLst/>
+          </a:prstGeom>
+        </p:spPr>
+      </p:pic>
+      <p:sp>
+        <p:nvSpPr>
+          <p:cNvPr id="14" name="Text 9"/>
+          <p:cNvSpPr/>
+          <p:nvPr/>
+        </p:nvSpPr>
+        <p:spPr>
+          <a:xfrm>
+            <a:off x="2011680" y="4727448"/>
+            <a:ext cx="3931920" cy="502920"/>
+          </a:xfrm>
+          <a:prstGeom prst="rect">
+            <a:avLst/>
+          </a:prstGeom>
+          <a:noFill/>
+          <a:ln/>
+        </p:spPr>
+        <p:txBody>
+          <a:bodyPr wrap="square" lIns="0" tIns="0" rIns="0" bIns="0" rtlCol="0" anchor="ctr"/>
+          <a:lstStyle/>
+          <a:p>
+            <a:pPr indent="0" marL="0">
+              <a:buNone/>
+            </a:pPr>
+            <a:r>
+              <a:rPr lang="en-US" sz="2000" b="1" dirty="0">
+                <a:solidFill>
+                  <a:srgbClr val="2F3C7E"/>
+                </a:solidFill>
+                <a:latin typeface="Cambria" pitchFamily="34" charset="0"/>
+                <a:ea typeface="Cambria" pitchFamily="34" charset="-122"/>
+                <a:cs typeface="Cambria" pitchFamily="34" charset="-120"/>
+              </a:rPr>
+              <a:t>Autonomie des familles</a:t>
+            </a:r>
+            <a:endParaRPr lang="en-US" sz="2000" dirty="0"/>
+          </a:p>
+        </p:txBody>
+      </p:sp>
+      <p:sp>
+        <p:nvSpPr>
+          <p:cNvPr id="15" name="Text 10"/>
+          <p:cNvSpPr/>
+          <p:nvPr/>
+        </p:nvSpPr>
+        <p:spPr>
+          <a:xfrm>
+            <a:off x="2011680" y="5212080"/>
+            <a:ext cx="5943600" cy="457200"/>
+          </a:xfrm>
+          <a:prstGeom prst="rect">
+            <a:avLst/>
+          </a:prstGeom>
+          <a:noFill/>
+          <a:ln/>
+        </p:spPr>
+        <p:txBody>
+          <a:bodyPr wrap="square" lIns="0" tIns="0" rIns="0" bIns="0" rtlCol="0" anchor="ctr"/>
+          <a:lstStyle/>
+          <a:p>
+            <a:pPr indent="0" marL="0">
+              <a:buNone/>
+            </a:pPr>
+            <a:r>
+              <a:rPr lang="en-US" sz="1400" dirty="0">
+                <a:solidFill>
+                  <a:srgbClr val="444444"/>
+                </a:solidFill>
+                <a:latin typeface="Calibri" pitchFamily="34" charset="0"/>
+                <a:ea typeface="Calibri" pitchFamily="34" charset="-122"/>
+                <a:cs typeface="Calibri" pitchFamily="34" charset="-120"/>
+              </a:rPr>
+              <a:t>Aider les familles à construire des ressources durables.</a:t>
+            </a:r>
+            <a:endParaRPr lang="en-US" sz="1400" dirty="0"/>
+          </a:p>
+        </p:txBody>
+      </p:sp>
+      <p:sp>
+        <p:nvSpPr>
+          <p:cNvPr id="16" name="Shape 11"/>
+          <p:cNvSpPr/>
+          <p:nvPr/>
+        </p:nvSpPr>
+        <p:spPr>
+          <a:xfrm>
+            <a:off x="8412480" y="2148840"/>
+            <a:ext cx="3108960" cy="3566160"/>
+          </a:xfrm>
+          <a:prstGeom prst="roundRect">
+            <a:avLst>
+              <a:gd name="adj" fmla="val 3529"/>
+            </a:avLst>
+          </a:prstGeom>
+          <a:solidFill>
+            <a:srgbClr val="94268F"/>
+          </a:solidFill>
+          <a:ln/>
+        </p:spPr>
+      </p:sp>
+      <p:sp>
+        <p:nvSpPr>
+          <p:cNvPr id="17" name="Text 12"/>
+          <p:cNvSpPr/>
+          <p:nvPr/>
+        </p:nvSpPr>
+        <p:spPr>
+          <a:xfrm>
+            <a:off x="8686800" y="2468880"/>
+            <a:ext cx="2560320" cy="1188720"/>
+          </a:xfrm>
+          <a:prstGeom prst="rect">
+            <a:avLst/>
+          </a:prstGeom>
+          <a:noFill/>
+          <a:ln/>
+        </p:spPr>
+        <p:txBody>
+          <a:bodyPr wrap="square" rtlCol="0" anchor="ctr"/>
+          <a:lstStyle/>
+          <a:p>
+            <a:pPr algn="ctr" indent="0" marL="0">
+              <a:buNone/>
+            </a:pPr>
+            <a:r>
+              <a:rPr lang="en-US" sz="1700" i="1" dirty="0">
+                <a:solidFill>
+                  <a:srgbClr val="F9E795"/>
+                </a:solidFill>
+                <a:latin typeface="Cambria" pitchFamily="34" charset="0"/>
+                <a:ea typeface="Cambria" pitchFamily="34" charset="-122"/>
+                <a:cs typeface="Cambria" pitchFamily="34" charset="-120"/>
+              </a:rPr>
+              <a:t>« Parce que chaque geste compte »</a:t>
+            </a:r>
+            <a:endParaRPr lang="en-US" sz="1700" dirty="0"/>
+          </a:p>
+        </p:txBody>
+      </p:sp>
+      <p:sp>
+        <p:nvSpPr>
+          <p:cNvPr id="18" name="Text 13"/>
+          <p:cNvSpPr/>
+          <p:nvPr/>
+        </p:nvSpPr>
+        <p:spPr>
+          <a:xfrm>
+            <a:off x="8686800" y="3749040"/>
+            <a:ext cx="2560320" cy="1737360"/>
+          </a:xfrm>
+          <a:prstGeom prst="rect">
+            <a:avLst/>
+          </a:prstGeom>
+          <a:noFill/>
+          <a:ln/>
+        </p:spPr>
+        <p:txBody>
+          <a:bodyPr wrap="square" rtlCol="0" anchor="ctr"/>
+          <a:lstStyle/>
+          <a:p>
+            <a:pPr algn="ctr" indent="0" marL="0">
+              <a:buNone/>
+            </a:pPr>
+            <a:r>
+              <a:rPr lang="en-US" sz="1300" dirty="0">
+                <a:solidFill>
+                  <a:srgbClr val="F2DDF0"/>
+                </a:solidFill>
+                <a:latin typeface="Calibri" pitchFamily="34" charset="0"/>
+                <a:ea typeface="Calibri" pitchFamily="34" charset="-122"/>
+                <a:cs typeface="Calibri" pitchFamily="34" charset="-120"/>
+              </a:rPr>
+              <a:t>D’une aide ponctuelle vers un véritable changement durable dans la vie des bénéficiaires.</a:t>
+            </a:r>
+            <a:endParaRPr lang="en-US" sz="1300" dirty="0"/>
+          </a:p>
+        </p:txBody>
+      </p:sp>
+    </p:spTree>
+  </p:cSld>
+  <p:clrMapOvr>
+    <a:masterClrMapping/>
+  </p:clrMapOvr>
+</p:sld>
+</file>
+
+<file path=ppt/slides/slide9.xml><?xml version="1.0" encoding="utf-8"?>
+<p:sld xmlns:a="http://schemas.openxmlformats.org/drawingml/2006/main" xmlns:r="http://schemas.openxmlformats.org/officeDocument/2006/relationships" xmlns:p="http://schemas.openxmlformats.org/presentationml/2006/main">
+  <p:cSld name="Slide 9">
     <p:bg>
       <p:bgPr>
         <a:solidFill>
@@ -5376,83 +6055,29 @@
       </p:sp>
       <p:sp>
         <p:nvSpPr>
-          <p:cNvPr id="4" name="Text 2"/>
-          <p:cNvSpPr/>
-          <p:nvPr/>
-        </p:nvSpPr>
-        <p:spPr>
-          <a:xfrm>
-            <a:off x="1097280" y="1188720"/>
-            <a:ext cx="9994392" cy="1463040"/>
-          </a:xfrm>
-          <a:prstGeom prst="rect">
-            <a:avLst/>
-          </a:prstGeom>
-          <a:noFill/>
-          <a:ln/>
-        </p:spPr>
-        <p:txBody>
-          <a:bodyPr wrap="square" rtlCol="0" anchor="ctr"/>
-          <a:lstStyle/>
-          <a:p>
-            <a:pPr algn="ctr" indent="0" marL="0">
-              <a:buNone/>
-            </a:pPr>
-            <a:r>
-              <a:rPr lang="en-US" sz="3000" b="1" i="1" dirty="0">
-                <a:solidFill>
-                  <a:srgbClr val="F9E795"/>
-                </a:solidFill>
-                <a:latin typeface="Cambria" pitchFamily="34" charset="0"/>
-                <a:ea typeface="Cambria" pitchFamily="34" charset="-122"/>
-                <a:cs typeface="Cambria" pitchFamily="34" charset="-120"/>
-              </a:rPr>
-              <a:t>« Seul, on peut faire un geste.</a:t>
-            </a:r>
-            <a:endParaRPr lang="en-US" sz="3000" dirty="0"/>
-          </a:p>
-          <a:p>
-            <a:pPr algn="ctr" indent="0" marL="0">
-              <a:buNone/>
-            </a:pPr>
-            <a:r>
-              <a:rPr lang="en-US" sz="3000" b="1" i="1" dirty="0">
-                <a:solidFill>
-                  <a:srgbClr val="F9E795"/>
-                </a:solidFill>
-                <a:latin typeface="Cambria" pitchFamily="34" charset="0"/>
-                <a:ea typeface="Cambria" pitchFamily="34" charset="-122"/>
-                <a:cs typeface="Cambria" pitchFamily="34" charset="-120"/>
-              </a:rPr>
-              <a:t>Ensemble, nous pouvons changer des vies. »</a:t>
-            </a:r>
-            <a:endParaRPr lang="en-US" sz="3000" dirty="0"/>
-          </a:p>
-        </p:txBody>
-      </p:sp>
-      <p:sp>
-        <p:nvSpPr>
-          <p:cNvPr id="5" name="Shape 3"/>
-          <p:cNvSpPr/>
-          <p:nvPr/>
-        </p:nvSpPr>
-        <p:spPr>
-          <a:xfrm>
-            <a:off x="2990088" y="3063240"/>
-            <a:ext cx="914400" cy="914400"/>
-          </a:xfrm>
-          <a:prstGeom prst="ellipse">
-            <a:avLst/>
-          </a:prstGeom>
-          <a:solidFill>
-            <a:srgbClr val="F96167"/>
+          <p:cNvPr id="4" name="Shape 2"/>
+          <p:cNvSpPr/>
+          <p:nvPr/>
+        </p:nvSpPr>
+        <p:spPr>
+          <a:xfrm>
+            <a:off x="5271516" y="320040"/>
+            <a:ext cx="1645920" cy="1645920"/>
+          </a:xfrm>
+          <a:prstGeom prst="roundRect">
+            <a:avLst>
+              <a:gd name="adj" fmla="val 6667"/>
+            </a:avLst>
+          </a:prstGeom>
+          <a:solidFill>
+            <a:srgbClr val="FFFFFF"/>
           </a:solidFill>
           <a:ln/>
         </p:spPr>
       </p:sp>
       <p:pic>
         <p:nvPicPr>
-          <p:cNvPr id="6" name="Image 0" descr="preencoded.png">    </p:cNvPr>
+          <p:cNvPr id="5" name="Image 0" descr="preencoded.png">    </p:cNvPr>
           <p:cNvPicPr>
             <a:picLocks noChangeAspect="1"/>
           </p:cNvPicPr>
@@ -5466,8 +6091,8 @@
         </p:blipFill>
         <p:spPr>
           <a:xfrm>
-            <a:off x="3227832" y="3300984"/>
-            <a:ext cx="438912" cy="438912"/>
+            <a:off x="5408676" y="457200"/>
+            <a:ext cx="1371600" cy="1371600"/>
           </a:xfrm>
           <a:prstGeom prst="rect">
             <a:avLst/>
@@ -5476,14 +6101,14 @@
       </p:pic>
       <p:sp>
         <p:nvSpPr>
-          <p:cNvPr id="7" name="Text 4"/>
-          <p:cNvSpPr/>
-          <p:nvPr/>
-        </p:nvSpPr>
-        <p:spPr>
-          <a:xfrm>
-            <a:off x="2212848" y="4069080"/>
-            <a:ext cx="2468880" cy="457200"/>
+          <p:cNvPr id="6" name="Text 3"/>
+          <p:cNvSpPr/>
+          <p:nvPr/>
+        </p:nvSpPr>
+        <p:spPr>
+          <a:xfrm>
+            <a:off x="1097280" y="2057400"/>
+            <a:ext cx="9994392" cy="1371600"/>
           </a:xfrm>
           <a:prstGeom prst="rect">
             <a:avLst/>
@@ -5499,43 +6124,60 @@
               <a:buNone/>
             </a:pPr>
             <a:r>
-              <a:rPr lang="en-US" sz="1500" b="1" dirty="0">
-                <a:solidFill>
-                  <a:srgbClr val="FFFFFF"/>
-                </a:solidFill>
-                <a:latin typeface="Calibri" pitchFamily="34" charset="0"/>
-                <a:ea typeface="Calibri" pitchFamily="34" charset="-122"/>
-                <a:cs typeface="Calibri" pitchFamily="34" charset="-120"/>
-              </a:rPr>
-              <a:t>Nos bénévoles</a:t>
-            </a:r>
-            <a:endParaRPr lang="en-US" sz="1500" dirty="0"/>
-          </a:p>
-        </p:txBody>
-      </p:sp>
-      <p:sp>
-        <p:nvSpPr>
-          <p:cNvPr id="8" name="Shape 5"/>
-          <p:cNvSpPr/>
-          <p:nvPr/>
-        </p:nvSpPr>
-        <p:spPr>
-          <a:xfrm>
-            <a:off x="5641848" y="3063240"/>
+              <a:rPr lang="en-US" sz="2800" b="1" i="1" dirty="0">
+                <a:solidFill>
+                  <a:srgbClr val="F9E795"/>
+                </a:solidFill>
+                <a:latin typeface="Cambria" pitchFamily="34" charset="0"/>
+                <a:ea typeface="Cambria" pitchFamily="34" charset="-122"/>
+                <a:cs typeface="Cambria" pitchFamily="34" charset="-120"/>
+              </a:rPr>
+              <a:t>« Seul, on peut faire un geste.</a:t>
+            </a:r>
+            <a:endParaRPr lang="en-US" sz="2800" dirty="0"/>
+          </a:p>
+          <a:p>
+            <a:pPr algn="ctr" indent="0" marL="0">
+              <a:buNone/>
+            </a:pPr>
+            <a:r>
+              <a:rPr lang="en-US" sz="2800" b="1" i="1" dirty="0">
+                <a:solidFill>
+                  <a:srgbClr val="F9E795"/>
+                </a:solidFill>
+                <a:latin typeface="Cambria" pitchFamily="34" charset="0"/>
+                <a:ea typeface="Cambria" pitchFamily="34" charset="-122"/>
+                <a:cs typeface="Cambria" pitchFamily="34" charset="-120"/>
+              </a:rPr>
+              <a:t>Ensemble, nous pouvons changer des vies. »</a:t>
+            </a:r>
+            <a:endParaRPr lang="en-US" sz="2800" dirty="0"/>
+          </a:p>
+        </p:txBody>
+      </p:sp>
+      <p:sp>
+        <p:nvSpPr>
+          <p:cNvPr id="7" name="Shape 4"/>
+          <p:cNvSpPr/>
+          <p:nvPr/>
+        </p:nvSpPr>
+        <p:spPr>
+          <a:xfrm>
+            <a:off x="2990088" y="3657600"/>
             <a:ext cx="914400" cy="914400"/>
           </a:xfrm>
           <a:prstGeom prst="ellipse">
             <a:avLst/>
           </a:prstGeom>
           <a:solidFill>
-            <a:srgbClr val="F96167"/>
+            <a:srgbClr val="F9931D"/>
           </a:solidFill>
           <a:ln/>
         </p:spPr>
       </p:sp>
       <p:pic>
         <p:nvPicPr>
-          <p:cNvPr id="9" name="Image 1" descr="preencoded.png">    </p:cNvPr>
+          <p:cNvPr id="8" name="Image 1" descr="preencoded.png">    </p:cNvPr>
           <p:cNvPicPr>
             <a:picLocks noChangeAspect="1"/>
           </p:cNvPicPr>
@@ -5549,7 +6191,7 @@
         </p:blipFill>
         <p:spPr>
           <a:xfrm>
-            <a:off x="5879592" y="3300984"/>
+            <a:off x="3227832" y="3895344"/>
             <a:ext cx="438912" cy="438912"/>
           </a:xfrm>
           <a:prstGeom prst="rect">
@@ -5559,13 +6201,13 @@
       </p:pic>
       <p:sp>
         <p:nvSpPr>
-          <p:cNvPr id="10" name="Text 6"/>
-          <p:cNvSpPr/>
-          <p:nvPr/>
-        </p:nvSpPr>
-        <p:spPr>
-          <a:xfrm>
-            <a:off x="4864608" y="4069080"/>
+          <p:cNvPr id="9" name="Text 5"/>
+          <p:cNvSpPr/>
+          <p:nvPr/>
+        </p:nvSpPr>
+        <p:spPr>
+          <a:xfrm>
+            <a:off x="2212848" y="4663440"/>
             <a:ext cx="2468880" cy="457200"/>
           </a:xfrm>
           <a:prstGeom prst="rect">
@@ -5590,7 +6232,7 @@
                 <a:ea typeface="Calibri" pitchFamily="34" charset="-122"/>
                 <a:cs typeface="Calibri" pitchFamily="34" charset="-120"/>
               </a:rPr>
-              <a:t>Nos donateurs</a:t>
+              <a:t>Nos bénévoles</a:t>
             </a:r>
             <a:endParaRPr lang="en-US" sz="1500" dirty="0"/>
           </a:p>
@@ -5598,27 +6240,27 @@
       </p:sp>
       <p:sp>
         <p:nvSpPr>
-          <p:cNvPr id="11" name="Shape 7"/>
-          <p:cNvSpPr/>
-          <p:nvPr/>
-        </p:nvSpPr>
-        <p:spPr>
-          <a:xfrm>
-            <a:off x="8293608" y="3063240"/>
+          <p:cNvPr id="10" name="Shape 6"/>
+          <p:cNvSpPr/>
+          <p:nvPr/>
+        </p:nvSpPr>
+        <p:spPr>
+          <a:xfrm>
+            <a:off x="5641848" y="3657600"/>
             <a:ext cx="914400" cy="914400"/>
           </a:xfrm>
           <a:prstGeom prst="ellipse">
             <a:avLst/>
           </a:prstGeom>
           <a:solidFill>
-            <a:srgbClr val="F96167"/>
+            <a:srgbClr val="45B84B"/>
           </a:solidFill>
           <a:ln/>
         </p:spPr>
       </p:sp>
       <p:pic>
         <p:nvPicPr>
-          <p:cNvPr id="12" name="Image 2" descr="preencoded.png">    </p:cNvPr>
+          <p:cNvPr id="11" name="Image 2" descr="preencoded.png">    </p:cNvPr>
           <p:cNvPicPr>
             <a:picLocks noChangeAspect="1"/>
           </p:cNvPicPr>
@@ -5632,7 +6274,7 @@
         </p:blipFill>
         <p:spPr>
           <a:xfrm>
-            <a:off x="8531352" y="3300984"/>
+            <a:off x="5879592" y="3895344"/>
             <a:ext cx="438912" cy="438912"/>
           </a:xfrm>
           <a:prstGeom prst="rect">
@@ -5642,13 +6284,13 @@
       </p:pic>
       <p:sp>
         <p:nvSpPr>
-          <p:cNvPr id="13" name="Text 8"/>
-          <p:cNvSpPr/>
-          <p:nvPr/>
-        </p:nvSpPr>
-        <p:spPr>
-          <a:xfrm>
-            <a:off x="7516368" y="4069080"/>
+          <p:cNvPr id="12" name="Text 7"/>
+          <p:cNvSpPr/>
+          <p:nvPr/>
+        </p:nvSpPr>
+        <p:spPr>
+          <a:xfrm>
+            <a:off x="4864608" y="4663440"/>
             <a:ext cx="2468880" cy="457200"/>
           </a:xfrm>
           <a:prstGeom prst="rect">
@@ -5673,7 +6315,7 @@
                 <a:ea typeface="Calibri" pitchFamily="34" charset="-122"/>
                 <a:cs typeface="Calibri" pitchFamily="34" charset="-120"/>
               </a:rPr>
-              <a:t>Nos partenaires</a:t>
+              <a:t>Nos donateurs</a:t>
             </a:r>
             <a:endParaRPr lang="en-US" sz="1500" dirty="0"/>
           </a:p>
@@ -5681,14 +6323,58 @@
       </p:sp>
       <p:sp>
         <p:nvSpPr>
-          <p:cNvPr id="14" name="Text 9"/>
-          <p:cNvSpPr/>
-          <p:nvPr/>
-        </p:nvSpPr>
-        <p:spPr>
-          <a:xfrm>
-            <a:off x="1097280" y="5029200"/>
-            <a:ext cx="9994392" cy="914400"/>
+          <p:cNvPr id="13" name="Shape 8"/>
+          <p:cNvSpPr/>
+          <p:nvPr/>
+        </p:nvSpPr>
+        <p:spPr>
+          <a:xfrm>
+            <a:off x="8293608" y="3657600"/>
+            <a:ext cx="914400" cy="914400"/>
+          </a:xfrm>
+          <a:prstGeom prst="ellipse">
+            <a:avLst/>
+          </a:prstGeom>
+          <a:solidFill>
+            <a:srgbClr val="94268F"/>
+          </a:solidFill>
+          <a:ln/>
+        </p:spPr>
+      </p:sp>
+      <p:pic>
+        <p:nvPicPr>
+          <p:cNvPr id="14" name="Image 3" descr="preencoded.png">    </p:cNvPr>
+          <p:cNvPicPr>
+            <a:picLocks noChangeAspect="1"/>
+          </p:cNvPicPr>
+          <p:nvPr/>
+        </p:nvPicPr>
+        <p:blipFill>
+          <a:blip r:embed="rId4"/>
+          <a:stretch>
+            <a:fillRect/>
+          </a:stretch>
+        </p:blipFill>
+        <p:spPr>
+          <a:xfrm>
+            <a:off x="8531352" y="3895344"/>
+            <a:ext cx="438912" cy="438912"/>
+          </a:xfrm>
+          <a:prstGeom prst="rect">
+            <a:avLst/>
+          </a:prstGeom>
+        </p:spPr>
+      </p:pic>
+      <p:sp>
+        <p:nvSpPr>
+          <p:cNvPr id="15" name="Text 9"/>
+          <p:cNvSpPr/>
+          <p:nvPr/>
+        </p:nvSpPr>
+        <p:spPr>
+          <a:xfrm>
+            <a:off x="7516368" y="4663440"/>
+            <a:ext cx="2468880" cy="457200"/>
           </a:xfrm>
           <a:prstGeom prst="rect">
             <a:avLst/>
@@ -5704,24 +6390,46 @@
               <a:buNone/>
             </a:pPr>
             <a:r>
-              <a:rPr lang="en-US" sz="1500" dirty="0">
-                <a:solidFill>
-                  <a:srgbClr val="C9CFEA"/>
+              <a:rPr lang="en-US" sz="1500" b="1" dirty="0">
+                <a:solidFill>
+                  <a:srgbClr val="FFFFFF"/>
                 </a:solidFill>
                 <a:latin typeface="Calibri" pitchFamily="34" charset="0"/>
                 <a:ea typeface="Calibri" pitchFamily="34" charset="-122"/>
                 <a:cs typeface="Calibri" pitchFamily="34" charset="-120"/>
               </a:rPr>
-              <a:t>Merci pour votre présence, votre confiance et votre soutien.</a:t>
+              <a:t>Nos partenaires</a:t>
             </a:r>
             <a:endParaRPr lang="en-US" sz="1500" dirty="0"/>
           </a:p>
+        </p:txBody>
+      </p:sp>
+      <p:sp>
+        <p:nvSpPr>
+          <p:cNvPr id="16" name="Text 10"/>
+          <p:cNvSpPr/>
+          <p:nvPr/>
+        </p:nvSpPr>
+        <p:spPr>
+          <a:xfrm>
+            <a:off x="1097280" y="5349240"/>
+            <a:ext cx="9994392" cy="822960"/>
+          </a:xfrm>
+          <a:prstGeom prst="rect">
+            <a:avLst/>
+          </a:prstGeom>
+          <a:noFill/>
+          <a:ln/>
+        </p:spPr>
+        <p:txBody>
+          <a:bodyPr wrap="square" rtlCol="0" anchor="ctr"/>
+          <a:lstStyle/>
           <a:p>
             <a:pPr algn="ctr" indent="0" marL="0">
               <a:buNone/>
             </a:pPr>
             <a:r>
-              <a:rPr lang="en-US" sz="1500" dirty="0">
+              <a:rPr lang="en-US" sz="1400" dirty="0">
                 <a:solidFill>
                   <a:srgbClr val="C9CFEA"/>
                 </a:solidFill>
@@ -5729,22 +6437,39 @@
                 <a:ea typeface="Calibri" pitchFamily="34" charset="-122"/>
                 <a:cs typeface="Calibri" pitchFamily="34" charset="-120"/>
               </a:rPr>
+              <a:t>Merci pour votre présence, votre confiance et votre soutien.</a:t>
+            </a:r>
+            <a:endParaRPr lang="en-US" sz="1400" dirty="0"/>
+          </a:p>
+          <a:p>
+            <a:pPr algn="ctr" indent="0" marL="0">
+              <a:buNone/>
+            </a:pPr>
+            <a:r>
+              <a:rPr lang="en-US" sz="1400" dirty="0">
+                <a:solidFill>
+                  <a:srgbClr val="C9CFEA"/>
+                </a:solidFill>
+                <a:latin typeface="Calibri" pitchFamily="34" charset="0"/>
+                <a:ea typeface="Calibri" pitchFamily="34" charset="-122"/>
+                <a:cs typeface="Calibri" pitchFamily="34" charset="-120"/>
+              </a:rPr>
               <a:t>C’est grâce à des personnes comme vous que cette belle aventure peut continuer.</a:t>
             </a:r>
-            <a:endParaRPr lang="en-US" sz="1500" dirty="0"/>
-          </a:p>
-        </p:txBody>
-      </p:sp>
-      <p:sp>
-        <p:nvSpPr>
-          <p:cNvPr id="15" name="Text 10"/>
-          <p:cNvSpPr/>
-          <p:nvPr/>
-        </p:nvSpPr>
-        <p:spPr>
-          <a:xfrm>
-            <a:off x="1097280" y="6035040"/>
-            <a:ext cx="9994392" cy="457200"/>
+            <a:endParaRPr lang="en-US" sz="1400" dirty="0"/>
+          </a:p>
+        </p:txBody>
+      </p:sp>
+      <p:sp>
+        <p:nvSpPr>
+          <p:cNvPr id="17" name="Text 11"/>
+          <p:cNvSpPr/>
+          <p:nvPr/>
+        </p:nvSpPr>
+        <p:spPr>
+          <a:xfrm>
+            <a:off x="1097280" y="6217920"/>
+            <a:ext cx="9994392" cy="411480"/>
           </a:xfrm>
           <a:prstGeom prst="rect">
             <a:avLst/>

</xml_diff>